<commit_message>
Ajoute la slide base de données SQL au Copilote Financier
Complete le recit chronologique (notebook 01) entre l'exploration des
donnees et la typologie : 7 tables + 3 vues SQL, l'interet d'une vue
partagee, l'exemple du Cap d'Agde (117,1 M€/2 operations), et le
comparatif chronometre pandas vs Spark. 19 slides, 3544 mots, 25.3 a
27.3 min, ratio 28.3%/71.7%.

Co-Authored-By: Claude Sonnet 5 <noreply@anthropic.com>
Claude-Session: https://claude.ai/code/session_01TM7etrgJpNuxUyCgHaSPew
</commit_message>
<xml_diff>
--- a/soutenance_copilote_financier.pptx
+++ b/soutenance_copilote_financier.pptx
@@ -23,9 +23,10 @@
     <p:sldId id="271" r:id="rId17"/>
     <p:sldId id="272" r:id="rId18"/>
     <p:sldId id="273" r:id="rId19"/>
+    <p:sldId id="274" r:id="rId20"/>
   </p:sldIdLst>
   <p:notesMasterIdLst>
-    <p:notesMasterId r:id="rId20"/>
+    <p:notesMasterId r:id="rId21"/>
   </p:notesMasterIdLst>
   <p:sldSz cx="12192000" cy="6858000"/>
   <p:notesSz cx="6858000" cy="12192000"/>
@@ -1335,6 +1336,94 @@
             <a:fld id="{F7021451-1387-4CA6-816F-3879F97B5CBC}" type="slidenum">
               <a:rPr lang="en-US"/>
               <a:t>18</a:t>
+            </a:fld>
+            <a:endParaRPr lang="en-US"/>
+          </a:p>
+        </p:txBody>
+      </p:sp>
+    </p:spTree>
+    <p:extLst>
+      <p:ext uri="{BB962C8B-B14F-4D97-AF65-F5344CB8AC3E}">
+        <p14:creationId xmlns:p14="http://schemas.microsoft.com/office/powerpoint/2010/main" val="1024086991"/>
+      </p:ext>
+    </p:extLst>
+  </p:cSld>
+  <p:clrMapOvr>
+    <a:masterClrMapping/>
+  </p:clrMapOvr>
+</p:notes>
+</file>
+
+<file path=ppt/notesSlides/notesSlide19.xml><?xml version="1.0" encoding="utf-8"?>
+<p:notes xmlns:a="http://schemas.openxmlformats.org/drawingml/2006/main" xmlns:r="http://schemas.openxmlformats.org/officeDocument/2006/relationships" xmlns:p="http://schemas.openxmlformats.org/presentationml/2006/main">
+  <p:cSld>
+    <p:spTree>
+      <p:nvGrpSpPr>
+        <p:cNvPr id="1" name=""/>
+        <p:cNvGrpSpPr/>
+        <p:nvPr/>
+      </p:nvGrpSpPr>
+      <p:grpSpPr>
+        <a:xfrm>
+          <a:off x="0" y="0"/>
+          <a:ext cx="0" cy="0"/>
+          <a:chOff x="0" y="0"/>
+          <a:chExt cx="0" cy="0"/>
+        </a:xfrm>
+      </p:grpSpPr>
+      <p:sp>
+        <p:nvSpPr>
+          <p:cNvPr id="2" name="Slide Image Placeholder 1"/>
+          <p:cNvSpPr>
+            <a:spLocks noGrp="1" noRot="1" noChangeAspect="1"/>
+          </p:cNvSpPr>
+          <p:nvPr>
+            <p:ph type="sldImg"/>
+          </p:nvPr>
+        </p:nvSpPr>
+        <p:spPr/>
+      </p:sp>
+      <p:sp>
+        <p:nvSpPr>
+          <p:cNvPr id="3" name="Notes Placeholder 2"/>
+          <p:cNvSpPr>
+            <a:spLocks noGrp="1"/>
+          </p:cNvSpPr>
+          <p:nvPr>
+            <p:ph type="body" idx="1"/>
+          </p:nvPr>
+        </p:nvSpPr>
+        <p:spPr/>
+        <p:txBody>
+          <a:bodyPr/>
+          <a:lstStyle/>
+          <a:p>
+            <a:r>
+              <a:rPr lang="en-US" dirty="0"/>
+              <a:t/>
+            </a:r>
+            <a:endParaRPr lang="en-US" dirty="0"/>
+          </a:p>
+        </p:txBody>
+      </p:sp>
+      <p:sp>
+        <p:nvSpPr>
+          <p:cNvPr id="4" name="Slide Number Placeholder 3"/>
+          <p:cNvSpPr>
+            <a:spLocks noGrp="1"/>
+          </p:cNvSpPr>
+          <p:nvPr>
+            <p:ph type="sldNum" sz="quarter" idx="10"/>
+          </p:nvPr>
+        </p:nvSpPr>
+        <p:spPr/>
+        <p:txBody>
+          <a:bodyPr/>
+          <a:lstStyle/>
+          <a:p>
+            <a:fld id="{F7021451-1387-4CA6-816F-3879F97B5CBC}" type="slidenum">
+              <a:rPr lang="en-US"/>
+              <a:t>19</a:t>
             </a:fld>
             <a:endParaRPr lang="en-US"/>
           </a:p>
@@ -2616,7 +2705,7 @@
                 <a:ea typeface="Calibri" pitchFamily="34" charset="-122"/>
                 <a:cs typeface="Calibri" pitchFamily="34" charset="-120"/>
               </a:rPr>
-              <a:t>COPILOTE FINANCIER — UNE ÉTAPE AVANT L'AXE A</a:t>
+              <a:t>COPILOTE FINANCIER — INFRASTRUCTURE (NOTEBOOK 01)</a:t>
             </a:r>
             <a:endParaRPr lang="en-US" sz="1200" dirty="0"/>
           </a:p>
@@ -2655,7 +2744,7 @@
                 <a:ea typeface="Cambria" pitchFamily="34" charset="-122"/>
                 <a:cs typeface="Cambria" pitchFamily="34" charset="-120"/>
               </a:rPr>
-              <a:t>La typologie des opérations</a:t>
+              <a:t>La base de données SQL</a:t>
             </a:r>
             <a:endParaRPr lang="en-US" sz="2800" dirty="0"/>
           </a:p>
@@ -2669,46 +2758,7 @@
         </p:nvSpPr>
         <p:spPr>
           <a:xfrm>
-            <a:off x="548640" y="1517904"/>
-            <a:ext cx="11064240" cy="548640"/>
-          </a:xfrm>
-          <a:prstGeom prst="rect">
-            <a:avLst/>
-          </a:prstGeom>
-          <a:noFill/>
-          <a:ln/>
-        </p:spPr>
-        <p:txBody>
-          <a:bodyPr wrap="square" lIns="0" tIns="0" rIns="0" bIns="0" rtlCol="0" anchor="ctr"/>
-          <a:lstStyle/>
-          <a:p>
-            <a:pPr indent="0" marL="0">
-              <a:buNone/>
-            </a:pPr>
-            <a:r>
-              <a:rPr lang="en-US" sz="1400" i="1" dirty="0">
-                <a:solidFill>
-                  <a:srgbClr val="52514E"/>
-                </a:solidFill>
-                <a:latin typeface="Calibri" pitchFamily="34" charset="0"/>
-                <a:ea typeface="Calibri" pitchFamily="34" charset="-122"/>
-                <a:cs typeface="Calibri" pitchFamily="34" charset="-120"/>
-              </a:rPr>
-              <a:t>Comparer une opération de 2 M€ à une de 50 M€ sur leurs montants bruts n'a pas de sens : c'est la structure du budget qui les distingue.</a:t>
-            </a:r>
-            <a:endParaRPr lang="en-US" sz="1400" dirty="0"/>
-          </a:p>
-        </p:txBody>
-      </p:sp>
-      <p:sp>
-        <p:nvSpPr>
-          <p:cNvPr id="5" name="Text 3"/>
-          <p:cNvSpPr/>
-          <p:nvPr/>
-        </p:nvSpPr>
-        <p:spPr>
-          <a:xfrm>
-            <a:off x="548640" y="2240280"/>
+            <a:off x="548640" y="1600200"/>
             <a:ext cx="11064240" cy="1737360"/>
           </a:xfrm>
           <a:prstGeom prst="rect">
@@ -2726,13 +2776,13 @@
                 <a:spcPct val="106000"/>
               </a:lnSpc>
               <a:spcAft>
-                <a:spcPts val="1400"/>
+                <a:spcPts val="1000"/>
               </a:spcAft>
               <a:buSzPct val="100000"/>
               <a:buChar char="•"/>
             </a:pPr>
             <a:r>
-              <a:rPr lang="en-US" sz="1500" dirty="0">
+              <a:rPr lang="en-US" sz="1400" dirty="0">
                 <a:solidFill>
                   <a:srgbClr val="1A1A19"/>
                 </a:solidFill>
@@ -2740,9 +2790,9 @@
                 <a:ea typeface="Calibri" pitchFamily="34" charset="-122"/>
                 <a:cs typeface="Calibri" pitchFamily="34" charset="-120"/>
               </a:rPr>
-              <a:t>ACP (analyse en composantes principales) : 2 axes résument 61 % de la structure des coûts, vérifié par une seconde méthode indépendante (SVD)</a:t>
-            </a:r>
-            <a:endParaRPr lang="en-US" sz="1500" dirty="0"/>
+              <a:t>Les 4 exports Excel transformés en base SQLite : 7 tables + 3 vues SQL métier (marge par opération, réservations par mois, état du stock)</a:t>
+            </a:r>
+            <a:endParaRPr lang="en-US" sz="1400" dirty="0"/>
           </a:p>
           <a:p>
             <a:pPr marL="203200" indent="-203200">
@@ -2750,13 +2800,13 @@
                 <a:spcPct val="106000"/>
               </a:lnSpc>
               <a:spcAft>
-                <a:spcPts val="1400"/>
+                <a:spcPts val="1000"/>
               </a:spcAft>
               <a:buSzPct val="100000"/>
               <a:buChar char="•"/>
             </a:pPr>
             <a:r>
-              <a:rPr lang="en-US" sz="1500" dirty="0">
+              <a:rPr lang="en-US" sz="1400" dirty="0">
                 <a:solidFill>
                   <a:srgbClr val="1A1A19"/>
                 </a:solidFill>
@@ -2764,22 +2814,46 @@
                 <a:ea typeface="Calibri" pitchFamily="34" charset="-122"/>
                 <a:cs typeface="Calibri" pitchFamily="34" charset="-120"/>
               </a:rPr>
-              <a:t>Croisée avec une classification non supervisée : 4 familles d'opérations — résidentiel classique, aménagement foncier, promotion sur foncier allégé, aménagement lourd VRD</a:t>
-            </a:r>
-            <a:endParaRPr lang="en-US" sz="1500" dirty="0"/>
-          </a:p>
-        </p:txBody>
-      </p:sp>
-      <p:sp>
-        <p:nvSpPr>
-          <p:cNvPr id="6" name="Shape 4"/>
+              <a:t>Une vue n'est écrite qu'une fois : notebooks et plateforme partagent la même définition de chaque indicateur, au lieu de la recopier</a:t>
+            </a:r>
+            <a:endParaRPr lang="en-US" sz="1400" dirty="0"/>
+          </a:p>
+          <a:p>
+            <a:pPr marL="203200" indent="-203200">
+              <a:lnSpc>
+                <a:spcPct val="106000"/>
+              </a:lnSpc>
+              <a:spcAft>
+                <a:spcPts val="1000"/>
+              </a:spcAft>
+              <a:buSzPct val="100000"/>
+              <a:buChar char="•"/>
+            </a:pPr>
+            <a:r>
+              <a:rPr lang="en-US" sz="1400" dirty="0">
+                <a:solidFill>
+                  <a:srgbClr val="1A1A19"/>
+                </a:solidFill>
+                <a:latin typeface="Calibri" pitchFamily="34" charset="0"/>
+                <a:ea typeface="Calibri" pitchFamily="34" charset="-122"/>
+                <a:cs typeface="Calibri" pitchFamily="34" charset="-120"/>
+              </a:rPr>
+              <a:t>Comparatif chronométré honnêtement avec Spark, pour vérifier le chemin de montée en charge si le Copilote devait couvrir tout le groupe Nexity</a:t>
+            </a:r>
+            <a:endParaRPr lang="en-US" sz="1400" dirty="0"/>
+          </a:p>
+        </p:txBody>
+      </p:sp>
+      <p:sp>
+        <p:nvSpPr>
+          <p:cNvPr id="5" name="Shape 3"/>
           <p:cNvSpPr/>
           <p:nvPr/>
         </p:nvSpPr>
         <p:spPr>
           <a:xfrm>
             <a:off x="548640" y="4206240"/>
-            <a:ext cx="5394960" cy="1737360"/>
+            <a:ext cx="3566160" cy="1737360"/>
           </a:xfrm>
           <a:prstGeom prst="roundRect">
             <a:avLst>
@@ -2806,14 +2880,14 @@
       </p:sp>
       <p:sp>
         <p:nvSpPr>
-          <p:cNvPr id="7" name="Text 5"/>
+          <p:cNvPr id="6" name="Text 4"/>
           <p:cNvSpPr/>
           <p:nvPr/>
         </p:nvSpPr>
         <p:spPr>
           <a:xfrm>
             <a:off x="658368" y="4279392"/>
-            <a:ext cx="5175504" cy="1188720"/>
+            <a:ext cx="3346704" cy="1188720"/>
           </a:xfrm>
           <a:prstGeom prst="rect">
             <a:avLst/>
@@ -2829,7 +2903,7 @@
               <a:buNone/>
             </a:pPr>
             <a:r>
-              <a:rPr lang="en-US" sz="2800" b="1" dirty="0">
+              <a:rPr lang="en-US" sz="2600" b="1" dirty="0">
                 <a:solidFill>
                   <a:srgbClr val="EDA100"/>
                 </a:solidFill>
@@ -2837,22 +2911,22 @@
                 <a:ea typeface="Cambria" pitchFamily="34" charset="-122"/>
                 <a:cs typeface="Cambria" pitchFamily="34" charset="-120"/>
               </a:rPr>
-              <a:t>61 %</a:t>
-            </a:r>
-            <a:endParaRPr lang="en-US" sz="2800" dirty="0"/>
-          </a:p>
-        </p:txBody>
-      </p:sp>
-      <p:sp>
-        <p:nvSpPr>
-          <p:cNvPr id="8" name="Text 6"/>
+              <a:t>7 + 3</a:t>
+            </a:r>
+            <a:endParaRPr lang="en-US" sz="2600" dirty="0"/>
+          </a:p>
+        </p:txBody>
+      </p:sp>
+      <p:sp>
+        <p:nvSpPr>
+          <p:cNvPr id="7" name="Text 5"/>
           <p:cNvSpPr/>
           <p:nvPr/>
         </p:nvSpPr>
         <p:spPr>
           <a:xfrm>
             <a:off x="658368" y="5504688"/>
-            <a:ext cx="5175504" cy="384048"/>
+            <a:ext cx="3346704" cy="384048"/>
           </a:xfrm>
           <a:prstGeom prst="rect">
             <a:avLst/>
@@ -2876,7 +2950,7 @@
                 <a:ea typeface="Calibri" pitchFamily="34" charset="-122"/>
                 <a:cs typeface="Calibri" pitchFamily="34" charset="-120"/>
               </a:rPr>
-              <a:t>de la structure des coûts résumée par 2 axes de l'ACP</a:t>
+              <a:t>tables et vues SQL métier construites</a:t>
             </a:r>
             <a:endParaRPr lang="en-US" sz="1050" dirty="0"/>
           </a:p>
@@ -2884,14 +2958,14 @@
       </p:sp>
       <p:sp>
         <p:nvSpPr>
-          <p:cNvPr id="9" name="Shape 7"/>
-          <p:cNvSpPr/>
-          <p:nvPr/>
-        </p:nvSpPr>
-        <p:spPr>
-          <a:xfrm>
-            <a:off x="6217920" y="4206240"/>
-            <a:ext cx="5394960" cy="1737360"/>
+          <p:cNvPr id="8" name="Shape 6"/>
+          <p:cNvSpPr/>
+          <p:nvPr/>
+        </p:nvSpPr>
+        <p:spPr>
+          <a:xfrm>
+            <a:off x="4297680" y="4206240"/>
+            <a:ext cx="3566160" cy="1737360"/>
           </a:xfrm>
           <a:prstGeom prst="roundRect">
             <a:avLst>
@@ -2918,14 +2992,14 @@
       </p:sp>
       <p:sp>
         <p:nvSpPr>
-          <p:cNvPr id="10" name="Text 8"/>
-          <p:cNvSpPr/>
-          <p:nvPr/>
-        </p:nvSpPr>
-        <p:spPr>
-          <a:xfrm>
-            <a:off x="6327648" y="4279392"/>
-            <a:ext cx="5175504" cy="1188720"/>
+          <p:cNvPr id="9" name="Text 7"/>
+          <p:cNvSpPr/>
+          <p:nvPr/>
+        </p:nvSpPr>
+        <p:spPr>
+          <a:xfrm>
+            <a:off x="4407408" y="4279392"/>
+            <a:ext cx="3346704" cy="1188720"/>
           </a:xfrm>
           <a:prstGeom prst="rect">
             <a:avLst/>
@@ -2949,7 +3023,7 @@
                 <a:ea typeface="Cambria" pitchFamily="34" charset="-122"/>
                 <a:cs typeface="Cambria" pitchFamily="34" charset="-120"/>
               </a:rPr>
-              <a:t>+7,9 % à +11,3 %</a:t>
+              <a:t>117,1 M€</a:t>
             </a:r>
             <a:endParaRPr lang="en-US" sz="2200" dirty="0"/>
           </a:p>
@@ -2957,14 +3031,14 @@
       </p:sp>
       <p:sp>
         <p:nvSpPr>
-          <p:cNvPr id="11" name="Text 9"/>
-          <p:cNvSpPr/>
-          <p:nvPr/>
-        </p:nvSpPr>
-        <p:spPr>
-          <a:xfrm>
-            <a:off x="6327648" y="5504688"/>
-            <a:ext cx="5175504" cy="384048"/>
+          <p:cNvPr id="10" name="Text 8"/>
+          <p:cNvSpPr/>
+          <p:nvPr/>
+        </p:nvSpPr>
+        <p:spPr>
+          <a:xfrm>
+            <a:off x="4407408" y="5504688"/>
+            <a:ext cx="3346704" cy="384048"/>
           </a:xfrm>
           <a:prstGeom prst="rect">
             <a:avLst/>
@@ -2988,7 +3062,7 @@
                 <a:ea typeface="Calibri" pitchFamily="34" charset="-122"/>
                 <a:cs typeface="Calibri" pitchFamily="34" charset="-120"/>
               </a:rPr>
-              <a:t>marges des 5 voisines du Parc des Cyclades (budget +6,5 %)</a:t>
+              <a:t>de CA budgété sur 2 opérations au Cap d'Agde</a:t>
             </a:r>
             <a:endParaRPr lang="en-US" sz="1050" dirty="0"/>
           </a:p>
@@ -2996,7 +3070,119 @@
       </p:sp>
       <p:sp>
         <p:nvSpPr>
+          <p:cNvPr id="11" name="Shape 9"/>
+          <p:cNvSpPr/>
+          <p:nvPr/>
+        </p:nvSpPr>
+        <p:spPr>
+          <a:xfrm>
+            <a:off x="8046720" y="4206240"/>
+            <a:ext cx="3566160" cy="1737360"/>
+          </a:xfrm>
+          <a:prstGeom prst="roundRect">
+            <a:avLst>
+              <a:gd name="adj" fmla="val 4211"/>
+            </a:avLst>
+          </a:prstGeom>
+          <a:solidFill>
+            <a:srgbClr val="FFFFFF"/>
+          </a:solidFill>
+          <a:ln w="12700">
+            <a:solidFill>
+              <a:srgbClr val="E3E7EE"/>
+            </a:solidFill>
+            <a:prstDash val="solid"/>
+          </a:ln>
+          <a:effectLst>
+            <a:outerShdw sx="100000" sy="100000" kx="0" ky="0" algn="bl" rotWithShape="0" blurRad="76200" dist="25400" dir="5400000">
+              <a:srgbClr val="1A1A19">
+                <a:alpha val="12000"/>
+              </a:srgbClr>
+            </a:outerShdw>
+          </a:effectLst>
+        </p:spPr>
+      </p:sp>
+      <p:sp>
+        <p:nvSpPr>
           <p:cNvPr id="12" name="Text 10"/>
+          <p:cNvSpPr/>
+          <p:nvPr/>
+        </p:nvSpPr>
+        <p:spPr>
+          <a:xfrm>
+            <a:off x="8156448" y="4279392"/>
+            <a:ext cx="3346704" cy="1188720"/>
+          </a:xfrm>
+          <a:prstGeom prst="rect">
+            <a:avLst/>
+          </a:prstGeom>
+          <a:noFill/>
+          <a:ln/>
+        </p:spPr>
+        <p:txBody>
+          <a:bodyPr wrap="square" lIns="0" tIns="0" rIns="0" bIns="0" rtlCol="0" anchor="b"/>
+          <a:lstStyle/>
+          <a:p>
+            <a:pPr algn="l" indent="0" marL="0">
+              <a:buNone/>
+            </a:pPr>
+            <a:r>
+              <a:rPr lang="en-US" sz="1600" b="1" dirty="0">
+                <a:solidFill>
+                  <a:srgbClr val="2A78D6"/>
+                </a:solidFill>
+                <a:latin typeface="Cambria" pitchFamily="34" charset="0"/>
+                <a:ea typeface="Cambria" pitchFamily="34" charset="-122"/>
+                <a:cs typeface="Cambria" pitchFamily="34" charset="-120"/>
+              </a:rPr>
+              <a:t>9,9 ms / 577,4 ms</a:t>
+            </a:r>
+            <a:endParaRPr lang="en-US" sz="1600" dirty="0"/>
+          </a:p>
+        </p:txBody>
+      </p:sp>
+      <p:sp>
+        <p:nvSpPr>
+          <p:cNvPr id="13" name="Text 11"/>
+          <p:cNvSpPr/>
+          <p:nvPr/>
+        </p:nvSpPr>
+        <p:spPr>
+          <a:xfrm>
+            <a:off x="8156448" y="5504688"/>
+            <a:ext cx="3346704" cy="384048"/>
+          </a:xfrm>
+          <a:prstGeom prst="rect">
+            <a:avLst/>
+          </a:prstGeom>
+          <a:noFill/>
+          <a:ln/>
+        </p:spPr>
+        <p:txBody>
+          <a:bodyPr wrap="square" lIns="0" tIns="0" rIns="0" bIns="0" rtlCol="0" anchor="t"/>
+          <a:lstStyle/>
+          <a:p>
+            <a:pPr algn="l" indent="0" marL="0">
+              <a:buNone/>
+            </a:pPr>
+            <a:r>
+              <a:rPr lang="en-US" sz="1050" dirty="0">
+                <a:solidFill>
+                  <a:srgbClr val="52514E"/>
+                </a:solidFill>
+                <a:latin typeface="Calibri" pitchFamily="34" charset="0"/>
+                <a:ea typeface="Calibri" pitchFamily="34" charset="-122"/>
+                <a:cs typeface="Calibri" pitchFamily="34" charset="-120"/>
+              </a:rPr>
+              <a:t>pandas vs Spark (+ 23,9 s de démarrage) — Spark surdimensionné ici</a:t>
+            </a:r>
+            <a:endParaRPr lang="en-US" sz="1050" dirty="0"/>
+          </a:p>
+        </p:txBody>
+      </p:sp>
+      <p:sp>
+        <p:nvSpPr>
+          <p:cNvPr id="14" name="Text 12"/>
           <p:cNvSpPr/>
           <p:nvPr/>
         </p:nvSpPr>
@@ -3027,7 +3213,7 @@
                 <a:ea typeface="Calibri" pitchFamily="34" charset="-122"/>
                 <a:cs typeface="Calibri" pitchFamily="34" charset="-120"/>
               </a:rPr>
-              <a:t>Cette typologie sert directement de comparateur dans l'axe A.</a:t>
+              <a:t>Cette base solidement posée, encore une étape avant l'axe A.</a:t>
             </a:r>
             <a:endParaRPr lang="en-US" sz="1200" dirty="0"/>
           </a:p>
@@ -3035,7 +3221,7 @@
       </p:sp>
       <p:sp>
         <p:nvSpPr>
-          <p:cNvPr id="13" name="Text 11"/>
+          <p:cNvPr id="15" name="Text 13"/>
           <p:cNvSpPr/>
           <p:nvPr/>
         </p:nvSpPr>
@@ -3074,7 +3260,7 @@
       </p:sp>
       <p:sp>
         <p:nvSpPr>
-          <p:cNvPr id="14" name="Text 12"/>
+          <p:cNvPr id="16" name="Text 14"/>
           <p:cNvSpPr/>
           <p:nvPr/>
         </p:nvSpPr>
@@ -3170,6 +3356,566 @@
             <a:r>
               <a:rPr lang="en-US" sz="1200" b="1" spc="200" kern="0" dirty="0">
                 <a:solidFill>
+                  <a:srgbClr val="EDA100"/>
+                </a:solidFill>
+                <a:latin typeface="Calibri" pitchFamily="34" charset="0"/>
+                <a:ea typeface="Calibri" pitchFamily="34" charset="-122"/>
+                <a:cs typeface="Calibri" pitchFamily="34" charset="-120"/>
+              </a:rPr>
+              <a:t>COPILOTE FINANCIER — UNE ÉTAPE AVANT L'AXE A</a:t>
+            </a:r>
+            <a:endParaRPr lang="en-US" sz="1200" dirty="0"/>
+          </a:p>
+        </p:txBody>
+      </p:sp>
+      <p:sp>
+        <p:nvSpPr>
+          <p:cNvPr id="3" name="Text 1"/>
+          <p:cNvSpPr/>
+          <p:nvPr/>
+        </p:nvSpPr>
+        <p:spPr>
+          <a:xfrm>
+            <a:off x="548640" y="658368"/>
+            <a:ext cx="10515600" cy="822960"/>
+          </a:xfrm>
+          <a:prstGeom prst="rect">
+            <a:avLst/>
+          </a:prstGeom>
+          <a:noFill/>
+          <a:ln/>
+        </p:spPr>
+        <p:txBody>
+          <a:bodyPr wrap="square" lIns="0" tIns="0" rIns="0" bIns="0" rtlCol="0" anchor="ctr"/>
+          <a:lstStyle/>
+          <a:p>
+            <a:pPr indent="0" marL="0">
+              <a:buNone/>
+            </a:pPr>
+            <a:r>
+              <a:rPr lang="en-US" sz="2800" b="1" dirty="0">
+                <a:solidFill>
+                  <a:srgbClr val="1A1A19"/>
+                </a:solidFill>
+                <a:latin typeface="Cambria" pitchFamily="34" charset="0"/>
+                <a:ea typeface="Cambria" pitchFamily="34" charset="-122"/>
+                <a:cs typeface="Cambria" pitchFamily="34" charset="-120"/>
+              </a:rPr>
+              <a:t>La typologie des opérations</a:t>
+            </a:r>
+            <a:endParaRPr lang="en-US" sz="2800" dirty="0"/>
+          </a:p>
+        </p:txBody>
+      </p:sp>
+      <p:sp>
+        <p:nvSpPr>
+          <p:cNvPr id="4" name="Text 2"/>
+          <p:cNvSpPr/>
+          <p:nvPr/>
+        </p:nvSpPr>
+        <p:spPr>
+          <a:xfrm>
+            <a:off x="548640" y="1517904"/>
+            <a:ext cx="11064240" cy="548640"/>
+          </a:xfrm>
+          <a:prstGeom prst="rect">
+            <a:avLst/>
+          </a:prstGeom>
+          <a:noFill/>
+          <a:ln/>
+        </p:spPr>
+        <p:txBody>
+          <a:bodyPr wrap="square" lIns="0" tIns="0" rIns="0" bIns="0" rtlCol="0" anchor="ctr"/>
+          <a:lstStyle/>
+          <a:p>
+            <a:pPr indent="0" marL="0">
+              <a:buNone/>
+            </a:pPr>
+            <a:r>
+              <a:rPr lang="en-US" sz="1400" i="1" dirty="0">
+                <a:solidFill>
+                  <a:srgbClr val="52514E"/>
+                </a:solidFill>
+                <a:latin typeface="Calibri" pitchFamily="34" charset="0"/>
+                <a:ea typeface="Calibri" pitchFamily="34" charset="-122"/>
+                <a:cs typeface="Calibri" pitchFamily="34" charset="-120"/>
+              </a:rPr>
+              <a:t>Comparer une opération de 2 M€ à une de 50 M€ sur leurs montants bruts n'a pas de sens : c'est la structure du budget qui les distingue.</a:t>
+            </a:r>
+            <a:endParaRPr lang="en-US" sz="1400" dirty="0"/>
+          </a:p>
+        </p:txBody>
+      </p:sp>
+      <p:sp>
+        <p:nvSpPr>
+          <p:cNvPr id="5" name="Text 3"/>
+          <p:cNvSpPr/>
+          <p:nvPr/>
+        </p:nvSpPr>
+        <p:spPr>
+          <a:xfrm>
+            <a:off x="548640" y="2240280"/>
+            <a:ext cx="11064240" cy="1737360"/>
+          </a:xfrm>
+          <a:prstGeom prst="rect">
+            <a:avLst/>
+          </a:prstGeom>
+          <a:noFill/>
+          <a:ln/>
+        </p:spPr>
+        <p:txBody>
+          <a:bodyPr wrap="square" lIns="0" tIns="0" rIns="0" bIns="0" rtlCol="0" anchor="t"/>
+          <a:lstStyle/>
+          <a:p>
+            <a:pPr marL="203200" indent="-203200">
+              <a:lnSpc>
+                <a:spcPct val="106000"/>
+              </a:lnSpc>
+              <a:spcAft>
+                <a:spcPts val="1400"/>
+              </a:spcAft>
+              <a:buSzPct val="100000"/>
+              <a:buChar char="•"/>
+            </a:pPr>
+            <a:r>
+              <a:rPr lang="en-US" sz="1500" dirty="0">
+                <a:solidFill>
+                  <a:srgbClr val="1A1A19"/>
+                </a:solidFill>
+                <a:latin typeface="Calibri" pitchFamily="34" charset="0"/>
+                <a:ea typeface="Calibri" pitchFamily="34" charset="-122"/>
+                <a:cs typeface="Calibri" pitchFamily="34" charset="-120"/>
+              </a:rPr>
+              <a:t>ACP (analyse en composantes principales) : 2 axes résument 61 % de la structure des coûts, vérifié par une seconde méthode indépendante (SVD)</a:t>
+            </a:r>
+            <a:endParaRPr lang="en-US" sz="1500" dirty="0"/>
+          </a:p>
+          <a:p>
+            <a:pPr marL="203200" indent="-203200">
+              <a:lnSpc>
+                <a:spcPct val="106000"/>
+              </a:lnSpc>
+              <a:spcAft>
+                <a:spcPts val="1400"/>
+              </a:spcAft>
+              <a:buSzPct val="100000"/>
+              <a:buChar char="•"/>
+            </a:pPr>
+            <a:r>
+              <a:rPr lang="en-US" sz="1500" dirty="0">
+                <a:solidFill>
+                  <a:srgbClr val="1A1A19"/>
+                </a:solidFill>
+                <a:latin typeface="Calibri" pitchFamily="34" charset="0"/>
+                <a:ea typeface="Calibri" pitchFamily="34" charset="-122"/>
+                <a:cs typeface="Calibri" pitchFamily="34" charset="-120"/>
+              </a:rPr>
+              <a:t>Croisée avec une classification non supervisée : 4 familles d'opérations — résidentiel classique, aménagement foncier, promotion sur foncier allégé, aménagement lourd VRD</a:t>
+            </a:r>
+            <a:endParaRPr lang="en-US" sz="1500" dirty="0"/>
+          </a:p>
+        </p:txBody>
+      </p:sp>
+      <p:sp>
+        <p:nvSpPr>
+          <p:cNvPr id="6" name="Shape 4"/>
+          <p:cNvSpPr/>
+          <p:nvPr/>
+        </p:nvSpPr>
+        <p:spPr>
+          <a:xfrm>
+            <a:off x="548640" y="4206240"/>
+            <a:ext cx="5394960" cy="1737360"/>
+          </a:xfrm>
+          <a:prstGeom prst="roundRect">
+            <a:avLst>
+              <a:gd name="adj" fmla="val 4211"/>
+            </a:avLst>
+          </a:prstGeom>
+          <a:solidFill>
+            <a:srgbClr val="FFFFFF"/>
+          </a:solidFill>
+          <a:ln w="12700">
+            <a:solidFill>
+              <a:srgbClr val="E3E7EE"/>
+            </a:solidFill>
+            <a:prstDash val="solid"/>
+          </a:ln>
+          <a:effectLst>
+            <a:outerShdw sx="100000" sy="100000" kx="0" ky="0" algn="bl" rotWithShape="0" blurRad="76200" dist="25400" dir="5400000">
+              <a:srgbClr val="1A1A19">
+                <a:alpha val="12000"/>
+              </a:srgbClr>
+            </a:outerShdw>
+          </a:effectLst>
+        </p:spPr>
+      </p:sp>
+      <p:sp>
+        <p:nvSpPr>
+          <p:cNvPr id="7" name="Text 5"/>
+          <p:cNvSpPr/>
+          <p:nvPr/>
+        </p:nvSpPr>
+        <p:spPr>
+          <a:xfrm>
+            <a:off x="658368" y="4279392"/>
+            <a:ext cx="5175504" cy="1188720"/>
+          </a:xfrm>
+          <a:prstGeom prst="rect">
+            <a:avLst/>
+          </a:prstGeom>
+          <a:noFill/>
+          <a:ln/>
+        </p:spPr>
+        <p:txBody>
+          <a:bodyPr wrap="square" lIns="0" tIns="0" rIns="0" bIns="0" rtlCol="0" anchor="b"/>
+          <a:lstStyle/>
+          <a:p>
+            <a:pPr algn="l" indent="0" marL="0">
+              <a:buNone/>
+            </a:pPr>
+            <a:r>
+              <a:rPr lang="en-US" sz="2800" b="1" dirty="0">
+                <a:solidFill>
+                  <a:srgbClr val="EDA100"/>
+                </a:solidFill>
+                <a:latin typeface="Cambria" pitchFamily="34" charset="0"/>
+                <a:ea typeface="Cambria" pitchFamily="34" charset="-122"/>
+                <a:cs typeface="Cambria" pitchFamily="34" charset="-120"/>
+              </a:rPr>
+              <a:t>61 %</a:t>
+            </a:r>
+            <a:endParaRPr lang="en-US" sz="2800" dirty="0"/>
+          </a:p>
+        </p:txBody>
+      </p:sp>
+      <p:sp>
+        <p:nvSpPr>
+          <p:cNvPr id="8" name="Text 6"/>
+          <p:cNvSpPr/>
+          <p:nvPr/>
+        </p:nvSpPr>
+        <p:spPr>
+          <a:xfrm>
+            <a:off x="658368" y="5504688"/>
+            <a:ext cx="5175504" cy="384048"/>
+          </a:xfrm>
+          <a:prstGeom prst="rect">
+            <a:avLst/>
+          </a:prstGeom>
+          <a:noFill/>
+          <a:ln/>
+        </p:spPr>
+        <p:txBody>
+          <a:bodyPr wrap="square" lIns="0" tIns="0" rIns="0" bIns="0" rtlCol="0" anchor="t"/>
+          <a:lstStyle/>
+          <a:p>
+            <a:pPr algn="l" indent="0" marL="0">
+              <a:buNone/>
+            </a:pPr>
+            <a:r>
+              <a:rPr lang="en-US" sz="1050" dirty="0">
+                <a:solidFill>
+                  <a:srgbClr val="52514E"/>
+                </a:solidFill>
+                <a:latin typeface="Calibri" pitchFamily="34" charset="0"/>
+                <a:ea typeface="Calibri" pitchFamily="34" charset="-122"/>
+                <a:cs typeface="Calibri" pitchFamily="34" charset="-120"/>
+              </a:rPr>
+              <a:t>de la structure des coûts résumée par 2 axes de l'ACP</a:t>
+            </a:r>
+            <a:endParaRPr lang="en-US" sz="1050" dirty="0"/>
+          </a:p>
+        </p:txBody>
+      </p:sp>
+      <p:sp>
+        <p:nvSpPr>
+          <p:cNvPr id="9" name="Shape 7"/>
+          <p:cNvSpPr/>
+          <p:nvPr/>
+        </p:nvSpPr>
+        <p:spPr>
+          <a:xfrm>
+            <a:off x="6217920" y="4206240"/>
+            <a:ext cx="5394960" cy="1737360"/>
+          </a:xfrm>
+          <a:prstGeom prst="roundRect">
+            <a:avLst>
+              <a:gd name="adj" fmla="val 4211"/>
+            </a:avLst>
+          </a:prstGeom>
+          <a:solidFill>
+            <a:srgbClr val="FFFFFF"/>
+          </a:solidFill>
+          <a:ln w="12700">
+            <a:solidFill>
+              <a:srgbClr val="E3E7EE"/>
+            </a:solidFill>
+            <a:prstDash val="solid"/>
+          </a:ln>
+          <a:effectLst>
+            <a:outerShdw sx="100000" sy="100000" kx="0" ky="0" algn="bl" rotWithShape="0" blurRad="76200" dist="25400" dir="5400000">
+              <a:srgbClr val="1A1A19">
+                <a:alpha val="12000"/>
+              </a:srgbClr>
+            </a:outerShdw>
+          </a:effectLst>
+        </p:spPr>
+      </p:sp>
+      <p:sp>
+        <p:nvSpPr>
+          <p:cNvPr id="10" name="Text 8"/>
+          <p:cNvSpPr/>
+          <p:nvPr/>
+        </p:nvSpPr>
+        <p:spPr>
+          <a:xfrm>
+            <a:off x="6327648" y="4279392"/>
+            <a:ext cx="5175504" cy="1188720"/>
+          </a:xfrm>
+          <a:prstGeom prst="rect">
+            <a:avLst/>
+          </a:prstGeom>
+          <a:noFill/>
+          <a:ln/>
+        </p:spPr>
+        <p:txBody>
+          <a:bodyPr wrap="square" lIns="0" tIns="0" rIns="0" bIns="0" rtlCol="0" anchor="b"/>
+          <a:lstStyle/>
+          <a:p>
+            <a:pPr algn="l" indent="0" marL="0">
+              <a:buNone/>
+            </a:pPr>
+            <a:r>
+              <a:rPr lang="en-US" sz="2200" b="1" dirty="0">
+                <a:solidFill>
+                  <a:srgbClr val="4A3AA7"/>
+                </a:solidFill>
+                <a:latin typeface="Cambria" pitchFamily="34" charset="0"/>
+                <a:ea typeface="Cambria" pitchFamily="34" charset="-122"/>
+                <a:cs typeface="Cambria" pitchFamily="34" charset="-120"/>
+              </a:rPr>
+              <a:t>+7,9 % à +11,3 %</a:t>
+            </a:r>
+            <a:endParaRPr lang="en-US" sz="2200" dirty="0"/>
+          </a:p>
+        </p:txBody>
+      </p:sp>
+      <p:sp>
+        <p:nvSpPr>
+          <p:cNvPr id="11" name="Text 9"/>
+          <p:cNvSpPr/>
+          <p:nvPr/>
+        </p:nvSpPr>
+        <p:spPr>
+          <a:xfrm>
+            <a:off x="6327648" y="5504688"/>
+            <a:ext cx="5175504" cy="384048"/>
+          </a:xfrm>
+          <a:prstGeom prst="rect">
+            <a:avLst/>
+          </a:prstGeom>
+          <a:noFill/>
+          <a:ln/>
+        </p:spPr>
+        <p:txBody>
+          <a:bodyPr wrap="square" lIns="0" tIns="0" rIns="0" bIns="0" rtlCol="0" anchor="t"/>
+          <a:lstStyle/>
+          <a:p>
+            <a:pPr algn="l" indent="0" marL="0">
+              <a:buNone/>
+            </a:pPr>
+            <a:r>
+              <a:rPr lang="en-US" sz="1050" dirty="0">
+                <a:solidFill>
+                  <a:srgbClr val="52514E"/>
+                </a:solidFill>
+                <a:latin typeface="Calibri" pitchFamily="34" charset="0"/>
+                <a:ea typeface="Calibri" pitchFamily="34" charset="-122"/>
+                <a:cs typeface="Calibri" pitchFamily="34" charset="-120"/>
+              </a:rPr>
+              <a:t>marges des 5 voisines du Parc des Cyclades (budget +6,5 %)</a:t>
+            </a:r>
+            <a:endParaRPr lang="en-US" sz="1050" dirty="0"/>
+          </a:p>
+        </p:txBody>
+      </p:sp>
+      <p:sp>
+        <p:nvSpPr>
+          <p:cNvPr id="12" name="Text 10"/>
+          <p:cNvSpPr/>
+          <p:nvPr/>
+        </p:nvSpPr>
+        <p:spPr>
+          <a:xfrm>
+            <a:off x="548640" y="6080760"/>
+            <a:ext cx="11064240" cy="365760"/>
+          </a:xfrm>
+          <a:prstGeom prst="rect">
+            <a:avLst/>
+          </a:prstGeom>
+          <a:noFill/>
+          <a:ln/>
+        </p:spPr>
+        <p:txBody>
+          <a:bodyPr wrap="square" lIns="0" tIns="0" rIns="0" bIns="0" rtlCol="0" anchor="ctr"/>
+          <a:lstStyle/>
+          <a:p>
+            <a:pPr indent="0" marL="0">
+              <a:buNone/>
+            </a:pPr>
+            <a:r>
+              <a:rPr lang="en-US" sz="1200" b="1" i="1" dirty="0">
+                <a:solidFill>
+                  <a:srgbClr val="1A1A19"/>
+                </a:solidFill>
+                <a:latin typeface="Calibri" pitchFamily="34" charset="0"/>
+                <a:ea typeface="Calibri" pitchFamily="34" charset="-122"/>
+                <a:cs typeface="Calibri" pitchFamily="34" charset="-120"/>
+              </a:rPr>
+              <a:t>Cette typologie sert directement de comparateur dans l'axe A.</a:t>
+            </a:r>
+            <a:endParaRPr lang="en-US" sz="1200" dirty="0"/>
+          </a:p>
+        </p:txBody>
+      </p:sp>
+      <p:sp>
+        <p:nvSpPr>
+          <p:cNvPr id="13" name="Text 11"/>
+          <p:cNvSpPr/>
+          <p:nvPr/>
+        </p:nvSpPr>
+        <p:spPr>
+          <a:xfrm>
+            <a:off x="548640" y="6510528"/>
+            <a:ext cx="5486400" cy="274320"/>
+          </a:xfrm>
+          <a:prstGeom prst="rect">
+            <a:avLst/>
+          </a:prstGeom>
+          <a:noFill/>
+          <a:ln/>
+        </p:spPr>
+        <p:txBody>
+          <a:bodyPr wrap="square" lIns="0" tIns="0" rIns="0" bIns="0" rtlCol="0" anchor="ctr"/>
+          <a:lstStyle/>
+          <a:p>
+            <a:pPr indent="0" marL="0">
+              <a:buNone/>
+            </a:pPr>
+            <a:r>
+              <a:rPr lang="en-US" sz="900" dirty="0">
+                <a:solidFill>
+                  <a:srgbClr val="9A9A95"/>
+                </a:solidFill>
+                <a:latin typeface="Calibri" pitchFamily="34" charset="0"/>
+                <a:ea typeface="Calibri" pitchFamily="34" charset="-122"/>
+                <a:cs typeface="Calibri" pitchFamily="34" charset="-120"/>
+              </a:rPr>
+              <a:t>Copilote Financier — Groupe Angelotti</a:t>
+            </a:r>
+            <a:endParaRPr lang="en-US" sz="900" dirty="0"/>
+          </a:p>
+        </p:txBody>
+      </p:sp>
+      <p:sp>
+        <p:nvSpPr>
+          <p:cNvPr id="14" name="Text 12"/>
+          <p:cNvSpPr/>
+          <p:nvPr/>
+        </p:nvSpPr>
+        <p:spPr>
+          <a:xfrm>
+            <a:off x="11430000" y="6510528"/>
+            <a:ext cx="365760" cy="274320"/>
+          </a:xfrm>
+          <a:prstGeom prst="rect">
+            <a:avLst/>
+          </a:prstGeom>
+          <a:noFill/>
+          <a:ln/>
+        </p:spPr>
+        <p:txBody>
+          <a:bodyPr wrap="square" lIns="0" tIns="0" rIns="0" bIns="0" rtlCol="0" anchor="ctr"/>
+          <a:lstStyle/>
+          <a:p>
+            <a:pPr algn="r" indent="0" marL="0">
+              <a:buNone/>
+            </a:pPr>
+            <a:r>
+              <a:rPr lang="en-US" sz="900" dirty="0">
+                <a:solidFill>
+                  <a:srgbClr val="9A9A95"/>
+                </a:solidFill>
+                <a:latin typeface="Calibri" pitchFamily="34" charset="0"/>
+                <a:ea typeface="Calibri" pitchFamily="34" charset="-122"/>
+                <a:cs typeface="Calibri" pitchFamily="34" charset="-120"/>
+              </a:rPr>
+              <a:t>11</a:t>
+            </a:r>
+            <a:endParaRPr lang="en-US" sz="900" dirty="0"/>
+          </a:p>
+        </p:txBody>
+      </p:sp>
+    </p:spTree>
+  </p:cSld>
+  <p:clrMapOvr>
+    <a:masterClrMapping/>
+  </p:clrMapOvr>
+</p:sld>
+</file>
+
+<file path=ppt/slides/slide12.xml><?xml version="1.0" encoding="utf-8"?>
+<p:sld xmlns:a="http://schemas.openxmlformats.org/drawingml/2006/main" xmlns:r="http://schemas.openxmlformats.org/officeDocument/2006/relationships" xmlns:p="http://schemas.openxmlformats.org/presentationml/2006/main">
+  <p:cSld name="Slide 12">
+    <p:bg>
+      <p:bgPr>
+        <a:solidFill>
+          <a:srgbClr val="FFFFFF"/>
+        </a:solidFill>
+      </p:bgPr>
+    </p:bg>
+    <p:spTree>
+      <p:nvGrpSpPr>
+        <p:cNvPr id="1" name=""/>
+        <p:cNvGrpSpPr/>
+        <p:nvPr/>
+      </p:nvGrpSpPr>
+      <p:grpSpPr>
+        <a:xfrm>
+          <a:off x="0" y="0"/>
+          <a:ext cx="0" cy="0"/>
+          <a:chOff x="0" y="0"/>
+          <a:chExt cx="0" cy="0"/>
+        </a:xfrm>
+      </p:grpSpPr>
+      <p:sp>
+        <p:nvSpPr>
+          <p:cNvPr id="2" name="Text 0"/>
+          <p:cNvSpPr/>
+          <p:nvPr/>
+        </p:nvSpPr>
+        <p:spPr>
+          <a:xfrm>
+            <a:off x="548640" y="384048"/>
+            <a:ext cx="8229600" cy="320040"/>
+          </a:xfrm>
+          <a:prstGeom prst="rect">
+            <a:avLst/>
+          </a:prstGeom>
+          <a:noFill/>
+          <a:ln/>
+        </p:spPr>
+        <p:txBody>
+          <a:bodyPr wrap="square" lIns="0" tIns="0" rIns="0" bIns="0" rtlCol="0" anchor="ctr"/>
+          <a:lstStyle/>
+          <a:p>
+            <a:pPr indent="0" marL="0">
+              <a:buNone/>
+            </a:pPr>
+            <a:r>
+              <a:rPr lang="en-US" sz="1200" b="1" spc="200" kern="0" dirty="0">
+                <a:solidFill>
                   <a:srgbClr val="2A78D6"/>
                 </a:solidFill>
                 <a:latin typeface="Calibri" pitchFamily="34" charset="0"/>
@@ -3474,7 +4220,7 @@
       </p:sp>
       <p:graphicFrame>
         <p:nvGraphicFramePr>
-          <p:cNvPr id="12" name="Table 0"/>
+          <p:cNvPr id="13" name="Table 0"/>
           <p:cNvGraphicFramePr>
             <a:graphicFrameLocks noGrp="1"/>
           </p:cNvGraphicFramePr>
@@ -4440,647 +5186,6 @@
                 <a:ea typeface="Calibri" pitchFamily="34" charset="-122"/>
                 <a:cs typeface="Calibri" pitchFamily="34" charset="-120"/>
               </a:rPr>
-              <a:t>11</a:t>
-            </a:r>
-            <a:endParaRPr lang="en-US" sz="900" dirty="0"/>
-          </a:p>
-        </p:txBody>
-      </p:sp>
-    </p:spTree>
-  </p:cSld>
-  <p:clrMapOvr>
-    <a:masterClrMapping/>
-  </p:clrMapOvr>
-</p:sld>
-</file>
-
-<file path=ppt/slides/slide12.xml><?xml version="1.0" encoding="utf-8"?>
-<p:sld xmlns:a="http://schemas.openxmlformats.org/drawingml/2006/main" xmlns:r="http://schemas.openxmlformats.org/officeDocument/2006/relationships" xmlns:p="http://schemas.openxmlformats.org/presentationml/2006/main">
-  <p:cSld name="Slide 12">
-    <p:bg>
-      <p:bgPr>
-        <a:solidFill>
-          <a:srgbClr val="FFFFFF"/>
-        </a:solidFill>
-      </p:bgPr>
-    </p:bg>
-    <p:spTree>
-      <p:nvGrpSpPr>
-        <p:cNvPr id="1" name=""/>
-        <p:cNvGrpSpPr/>
-        <p:nvPr/>
-      </p:nvGrpSpPr>
-      <p:grpSpPr>
-        <a:xfrm>
-          <a:off x="0" y="0"/>
-          <a:ext cx="0" cy="0"/>
-          <a:chOff x="0" y="0"/>
-          <a:chExt cx="0" cy="0"/>
-        </a:xfrm>
-      </p:grpSpPr>
-      <p:sp>
-        <p:nvSpPr>
-          <p:cNvPr id="2" name="Text 0"/>
-          <p:cNvSpPr/>
-          <p:nvPr/>
-        </p:nvSpPr>
-        <p:spPr>
-          <a:xfrm>
-            <a:off x="548640" y="384048"/>
-            <a:ext cx="8229600" cy="320040"/>
-          </a:xfrm>
-          <a:prstGeom prst="rect">
-            <a:avLst/>
-          </a:prstGeom>
-          <a:noFill/>
-          <a:ln/>
-        </p:spPr>
-        <p:txBody>
-          <a:bodyPr wrap="square" lIns="0" tIns="0" rIns="0" bIns="0" rtlCol="0" anchor="ctr"/>
-          <a:lstStyle/>
-          <a:p>
-            <a:pPr indent="0" marL="0">
-              <a:buNone/>
-            </a:pPr>
-            <a:r>
-              <a:rPr lang="en-US" sz="1200" b="1" spc="200" kern="0" dirty="0">
-                <a:solidFill>
-                  <a:srgbClr val="1BAF7A"/>
-                </a:solidFill>
-                <a:latin typeface="Calibri" pitchFamily="34" charset="0"/>
-                <a:ea typeface="Calibri" pitchFamily="34" charset="-122"/>
-                <a:cs typeface="Calibri" pitchFamily="34" charset="-120"/>
-              </a:rPr>
-              <a:t>COPILOTE FINANCIER — AXE B</a:t>
-            </a:r>
-            <a:endParaRPr lang="en-US" sz="1200" dirty="0"/>
-          </a:p>
-        </p:txBody>
-      </p:sp>
-      <p:sp>
-        <p:nvSpPr>
-          <p:cNvPr id="3" name="Text 1"/>
-          <p:cNvSpPr/>
-          <p:nvPr/>
-        </p:nvSpPr>
-        <p:spPr>
-          <a:xfrm>
-            <a:off x="548640" y="658368"/>
-            <a:ext cx="7315200" cy="822960"/>
-          </a:xfrm>
-          <a:prstGeom prst="rect">
-            <a:avLst/>
-          </a:prstGeom>
-          <a:noFill/>
-          <a:ln/>
-        </p:spPr>
-        <p:txBody>
-          <a:bodyPr wrap="square" lIns="0" tIns="0" rIns="0" bIns="0" rtlCol="0" anchor="ctr"/>
-          <a:lstStyle/>
-          <a:p>
-            <a:pPr indent="0" marL="0">
-              <a:buNone/>
-            </a:pPr>
-            <a:r>
-              <a:rPr lang="en-US" sz="2800" b="1" dirty="0">
-                <a:solidFill>
-                  <a:srgbClr val="1A1A19"/>
-                </a:solidFill>
-                <a:latin typeface="Cambria" pitchFamily="34" charset="0"/>
-                <a:ea typeface="Cambria" pitchFamily="34" charset="-122"/>
-                <a:cs typeface="Cambria" pitchFamily="34" charset="-120"/>
-              </a:rPr>
-              <a:t>La vitesse d'écoulement</a:t>
-            </a:r>
-            <a:endParaRPr lang="en-US" sz="2800" dirty="0"/>
-          </a:p>
-        </p:txBody>
-      </p:sp>
-      <p:sp>
-        <p:nvSpPr>
-          <p:cNvPr id="4" name="Text 2"/>
-          <p:cNvSpPr/>
-          <p:nvPr/>
-        </p:nvSpPr>
-        <p:spPr>
-          <a:xfrm>
-            <a:off x="548640" y="1600200"/>
-            <a:ext cx="6309360" cy="3108960"/>
-          </a:xfrm>
-          <a:prstGeom prst="rect">
-            <a:avLst/>
-          </a:prstGeom>
-          <a:noFill/>
-          <a:ln/>
-        </p:spPr>
-        <p:txBody>
-          <a:bodyPr wrap="square" lIns="0" tIns="0" rIns="0" bIns="0" rtlCol="0" anchor="t"/>
-          <a:lstStyle/>
-          <a:p>
-            <a:pPr marL="203200" indent="-203200">
-              <a:lnSpc>
-                <a:spcPct val="106000"/>
-              </a:lnSpc>
-              <a:spcAft>
-                <a:spcPts val="1300"/>
-              </a:spcAft>
-              <a:buSzPct val="100000"/>
-              <a:buChar char="•"/>
-            </a:pPr>
-            <a:r>
-              <a:rPr lang="en-US" sz="1400" dirty="0">
-                <a:solidFill>
-                  <a:srgbClr val="1A1A19"/>
-                </a:solidFill>
-                <a:latin typeface="Calibri" pitchFamily="34" charset="0"/>
-                <a:ea typeface="Calibri" pitchFamily="34" charset="-122"/>
-                <a:cs typeface="Calibri" pitchFamily="34" charset="-120"/>
-              </a:rPr>
-              <a:t>Panel de 3 230 observations (opération × mois) — modèle à effets aléatoires</a:t>
-            </a:r>
-            <a:endParaRPr lang="en-US" sz="1400" dirty="0"/>
-          </a:p>
-          <a:p>
-            <a:pPr marL="203200" indent="-203200">
-              <a:lnSpc>
-                <a:spcPct val="106000"/>
-              </a:lnSpc>
-              <a:spcAft>
-                <a:spcPts val="1300"/>
-              </a:spcAft>
-              <a:buSzPct val="100000"/>
-              <a:buChar char="•"/>
-            </a:pPr>
-            <a:r>
-              <a:rPr lang="en-US" sz="1400" dirty="0">
-                <a:solidFill>
-                  <a:srgbClr val="1A1A19"/>
-                </a:solidFill>
-                <a:latin typeface="Calibri" pitchFamily="34" charset="0"/>
-                <a:ea typeface="Calibri" pitchFamily="34" charset="-122"/>
-                <a:cs typeface="Calibri" pitchFamily="34" charset="-120"/>
-              </a:rPr>
-              <a:t>2/3 de la variance = effet propre à l'opération, 1/3 = conjoncture</a:t>
-            </a:r>
-            <a:endParaRPr lang="en-US" sz="1400" dirty="0"/>
-          </a:p>
-          <a:p>
-            <a:pPr marL="203200" indent="-203200">
-              <a:lnSpc>
-                <a:spcPct val="106000"/>
-              </a:lnSpc>
-              <a:spcAft>
-                <a:spcPts val="1300"/>
-              </a:spcAft>
-              <a:buSzPct val="100000"/>
-              <a:buChar char="•"/>
-            </a:pPr>
-            <a:r>
-              <a:rPr lang="en-US" sz="1400" dirty="0">
-                <a:solidFill>
-                  <a:srgbClr val="1A1A19"/>
-                </a:solidFill>
-                <a:latin typeface="Calibri" pitchFamily="34" charset="0"/>
-                <a:ea typeface="Calibri" pitchFamily="34" charset="-122"/>
-                <a:cs typeface="Calibri" pitchFamily="34" charset="-120"/>
-              </a:rPr>
-              <a:t>Contrôle par série temporelle : effet du taux non identifiable isolément — validation méthodologique, pas un échec</a:t>
-            </a:r>
-            <a:endParaRPr lang="en-US" sz="1400" dirty="0"/>
-          </a:p>
-        </p:txBody>
-      </p:sp>
-      <p:sp>
-        <p:nvSpPr>
-          <p:cNvPr id="5" name="Shape 3"/>
-          <p:cNvSpPr/>
-          <p:nvPr/>
-        </p:nvSpPr>
-        <p:spPr>
-          <a:xfrm>
-            <a:off x="7013448" y="1618488"/>
-            <a:ext cx="4672584" cy="1956816"/>
-          </a:xfrm>
-          <a:prstGeom prst="roundRect">
-            <a:avLst>
-              <a:gd name="adj" fmla="val 2804"/>
-            </a:avLst>
-          </a:prstGeom>
-          <a:solidFill>
-            <a:srgbClr val="FFFFFF"/>
-          </a:solidFill>
-          <a:ln w="12700">
-            <a:solidFill>
-              <a:srgbClr val="E3E7EE"/>
-            </a:solidFill>
-            <a:prstDash val="solid"/>
-          </a:ln>
-          <a:effectLst>
-            <a:outerShdw sx="100000" sy="100000" kx="0" ky="0" algn="bl" rotWithShape="0" blurRad="101600" dist="25400" dir="5400000">
-              <a:srgbClr val="1A1A19">
-                <a:alpha val="15000"/>
-              </a:srgbClr>
-            </a:outerShdw>
-          </a:effectLst>
-        </p:spPr>
-      </p:sp>
-      <p:pic>
-        <p:nvPicPr>
-          <p:cNvPr id="6" name="Image 0" descr="/tmp/claude-0/-home-user-MemoireM2S2/bac073a6-7c4e-552a-9627-815aeb6fe82a/scratchpad/figs/p28-000.png">    </p:cNvPr>
-          <p:cNvPicPr>
-            <a:picLocks noChangeAspect="1"/>
-          </p:cNvPicPr>
-          <p:nvPr/>
-        </p:nvPicPr>
-        <p:blipFill>
-          <a:blip r:embed="rId1"/>
-          <a:srcRect l="0" r="0" t="0" b="0"/>
-          <a:stretch/>
-        </p:blipFill>
-        <p:spPr>
-          <a:xfrm>
-            <a:off x="7086600" y="1691640"/>
-            <a:ext cx="4526280" cy="1810512"/>
-          </a:xfrm>
-          <a:prstGeom prst="rect">
-            <a:avLst/>
-          </a:prstGeom>
-        </p:spPr>
-      </p:pic>
-      <p:sp>
-        <p:nvSpPr>
-          <p:cNvPr id="7" name="Text 4"/>
-          <p:cNvSpPr/>
-          <p:nvPr/>
-        </p:nvSpPr>
-        <p:spPr>
-          <a:xfrm>
-            <a:off x="7086600" y="3529584"/>
-            <a:ext cx="4526280" cy="411480"/>
-          </a:xfrm>
-          <a:prstGeom prst="rect">
-            <a:avLst/>
-          </a:prstGeom>
-          <a:noFill/>
-          <a:ln/>
-        </p:spPr>
-        <p:txBody>
-          <a:bodyPr wrap="square" lIns="0" tIns="0" rIns="0" bIns="0" rtlCol="0" anchor="ctr"/>
-          <a:lstStyle/>
-          <a:p>
-            <a:pPr indent="0" marL="0">
-              <a:buNone/>
-            </a:pPr>
-            <a:r>
-              <a:rPr lang="en-US" sz="950" i="1" dirty="0">
-                <a:solidFill>
-                  <a:srgbClr val="52514E"/>
-                </a:solidFill>
-                <a:latin typeface="Calibri" pitchFamily="34" charset="0"/>
-                <a:ea typeface="Calibri" pitchFamily="34" charset="-122"/>
-                <a:cs typeface="Calibri" pitchFamily="34" charset="-120"/>
-              </a:rPr>
-              <a:t>Fig. — Scénarios de taux 2026 : trajectoire ARIMA combinée à l'élasticité du panel</a:t>
-            </a:r>
-            <a:endParaRPr lang="en-US" sz="950" dirty="0"/>
-          </a:p>
-        </p:txBody>
-      </p:sp>
-      <p:sp>
-        <p:nvSpPr>
-          <p:cNvPr id="8" name="Shape 5"/>
-          <p:cNvSpPr/>
-          <p:nvPr/>
-        </p:nvSpPr>
-        <p:spPr>
-          <a:xfrm>
-            <a:off x="7086600" y="4251960"/>
-            <a:ext cx="2148840" cy="1417320"/>
-          </a:xfrm>
-          <a:prstGeom prst="roundRect">
-            <a:avLst>
-              <a:gd name="adj" fmla="val 5161"/>
-            </a:avLst>
-          </a:prstGeom>
-          <a:solidFill>
-            <a:srgbClr val="FFFFFF"/>
-          </a:solidFill>
-          <a:ln w="12700">
-            <a:solidFill>
-              <a:srgbClr val="E3E7EE"/>
-            </a:solidFill>
-            <a:prstDash val="solid"/>
-          </a:ln>
-          <a:effectLst>
-            <a:outerShdw sx="100000" sy="100000" kx="0" ky="0" algn="bl" rotWithShape="0" blurRad="76200" dist="25400" dir="5400000">
-              <a:srgbClr val="1A1A19">
-                <a:alpha val="12000"/>
-              </a:srgbClr>
-            </a:outerShdw>
-          </a:effectLst>
-        </p:spPr>
-      </p:sp>
-      <p:sp>
-        <p:nvSpPr>
-          <p:cNvPr id="9" name="Text 6"/>
-          <p:cNvSpPr/>
-          <p:nvPr/>
-        </p:nvSpPr>
-        <p:spPr>
-          <a:xfrm>
-            <a:off x="7196328" y="4325112"/>
-            <a:ext cx="1929384" cy="868680"/>
-          </a:xfrm>
-          <a:prstGeom prst="rect">
-            <a:avLst/>
-          </a:prstGeom>
-          <a:noFill/>
-          <a:ln/>
-        </p:spPr>
-        <p:txBody>
-          <a:bodyPr wrap="square" lIns="0" tIns="0" rIns="0" bIns="0" rtlCol="0" anchor="b"/>
-          <a:lstStyle/>
-          <a:p>
-            <a:pPr algn="l" indent="0" marL="0">
-              <a:buNone/>
-            </a:pPr>
-            <a:r>
-              <a:rPr lang="en-US" sz="2800" b="1" dirty="0">
-                <a:solidFill>
-                  <a:srgbClr val="1BAF7A"/>
-                </a:solidFill>
-                <a:latin typeface="Cambria" pitchFamily="34" charset="0"/>
-                <a:ea typeface="Cambria" pitchFamily="34" charset="-122"/>
-                <a:cs typeface="Cambria" pitchFamily="34" charset="-120"/>
-              </a:rPr>
-              <a:t>−19 %</a:t>
-            </a:r>
-            <a:endParaRPr lang="en-US" sz="2800" dirty="0"/>
-          </a:p>
-        </p:txBody>
-      </p:sp>
-      <p:sp>
-        <p:nvSpPr>
-          <p:cNvPr id="10" name="Text 7"/>
-          <p:cNvSpPr/>
-          <p:nvPr/>
-        </p:nvSpPr>
-        <p:spPr>
-          <a:xfrm>
-            <a:off x="7196328" y="5230368"/>
-            <a:ext cx="1929384" cy="384048"/>
-          </a:xfrm>
-          <a:prstGeom prst="rect">
-            <a:avLst/>
-          </a:prstGeom>
-          <a:noFill/>
-          <a:ln/>
-        </p:spPr>
-        <p:txBody>
-          <a:bodyPr wrap="square" lIns="0" tIns="0" rIns="0" bIns="0" rtlCol="0" anchor="t"/>
-          <a:lstStyle/>
-          <a:p>
-            <a:pPr algn="l" indent="0" marL="0">
-              <a:buNone/>
-            </a:pPr>
-            <a:r>
-              <a:rPr lang="en-US" sz="1050" dirty="0">
-                <a:solidFill>
-                  <a:srgbClr val="52514E"/>
-                </a:solidFill>
-                <a:latin typeface="Calibri" pitchFamily="34" charset="0"/>
-                <a:ea typeface="Calibri" pitchFamily="34" charset="-122"/>
-                <a:cs typeface="Calibri" pitchFamily="34" charset="-120"/>
-              </a:rPr>
-              <a:t>de réservations par point de taux en plus</a:t>
-            </a:r>
-            <a:endParaRPr lang="en-US" sz="1050" dirty="0"/>
-          </a:p>
-        </p:txBody>
-      </p:sp>
-      <p:sp>
-        <p:nvSpPr>
-          <p:cNvPr id="11" name="Shape 8"/>
-          <p:cNvSpPr/>
-          <p:nvPr/>
-        </p:nvSpPr>
-        <p:spPr>
-          <a:xfrm>
-            <a:off x="9464040" y="4251960"/>
-            <a:ext cx="2148840" cy="1417320"/>
-          </a:xfrm>
-          <a:prstGeom prst="roundRect">
-            <a:avLst>
-              <a:gd name="adj" fmla="val 5161"/>
-            </a:avLst>
-          </a:prstGeom>
-          <a:solidFill>
-            <a:srgbClr val="FFFFFF"/>
-          </a:solidFill>
-          <a:ln w="12700">
-            <a:solidFill>
-              <a:srgbClr val="E3E7EE"/>
-            </a:solidFill>
-            <a:prstDash val="solid"/>
-          </a:ln>
-          <a:effectLst>
-            <a:outerShdw sx="100000" sy="100000" kx="0" ky="0" algn="bl" rotWithShape="0" blurRad="76200" dist="25400" dir="5400000">
-              <a:srgbClr val="1A1A19">
-                <a:alpha val="12000"/>
-              </a:srgbClr>
-            </a:outerShdw>
-          </a:effectLst>
-        </p:spPr>
-      </p:sp>
-      <p:sp>
-        <p:nvSpPr>
-          <p:cNvPr id="12" name="Text 9"/>
-          <p:cNvSpPr/>
-          <p:nvPr/>
-        </p:nvSpPr>
-        <p:spPr>
-          <a:xfrm>
-            <a:off x="9573768" y="4325112"/>
-            <a:ext cx="1929384" cy="868680"/>
-          </a:xfrm>
-          <a:prstGeom prst="rect">
-            <a:avLst/>
-          </a:prstGeom>
-          <a:noFill/>
-          <a:ln/>
-        </p:spPr>
-        <p:txBody>
-          <a:bodyPr wrap="square" lIns="0" tIns="0" rIns="0" bIns="0" rtlCol="0" anchor="b"/>
-          <a:lstStyle/>
-          <a:p>
-            <a:pPr algn="l" indent="0" marL="0">
-              <a:buNone/>
-            </a:pPr>
-            <a:r>
-              <a:rPr lang="en-US" sz="2800" b="1" dirty="0">
-                <a:solidFill>
-                  <a:srgbClr val="2A78D6"/>
-                </a:solidFill>
-                <a:latin typeface="Cambria" pitchFamily="34" charset="0"/>
-                <a:ea typeface="Cambria" pitchFamily="34" charset="-122"/>
-                <a:cs typeface="Cambria" pitchFamily="34" charset="-120"/>
-              </a:rPr>
-              <a:t>20 mois</a:t>
-            </a:r>
-            <a:endParaRPr lang="en-US" sz="2800" dirty="0"/>
-          </a:p>
-        </p:txBody>
-      </p:sp>
-      <p:sp>
-        <p:nvSpPr>
-          <p:cNvPr id="13" name="Text 10"/>
-          <p:cNvSpPr/>
-          <p:nvPr/>
-        </p:nvSpPr>
-        <p:spPr>
-          <a:xfrm>
-            <a:off x="9573768" y="5230368"/>
-            <a:ext cx="1929384" cy="384048"/>
-          </a:xfrm>
-          <a:prstGeom prst="rect">
-            <a:avLst/>
-          </a:prstGeom>
-          <a:noFill/>
-          <a:ln/>
-        </p:spPr>
-        <p:txBody>
-          <a:bodyPr wrap="square" lIns="0" tIns="0" rIns="0" bIns="0" rtlCol="0" anchor="t"/>
-          <a:lstStyle/>
-          <a:p>
-            <a:pPr algn="l" indent="0" marL="0">
-              <a:buNone/>
-            </a:pPr>
-            <a:r>
-              <a:rPr lang="en-US" sz="1050" dirty="0">
-                <a:solidFill>
-                  <a:srgbClr val="52514E"/>
-                </a:solidFill>
-                <a:latin typeface="Calibri" pitchFamily="34" charset="0"/>
-                <a:ea typeface="Calibri" pitchFamily="34" charset="-122"/>
-                <a:cs typeface="Calibri" pitchFamily="34" charset="-120"/>
-              </a:rPr>
-              <a:t>délai médian pour 90 % du potentiel vendu</a:t>
-            </a:r>
-            <a:endParaRPr lang="en-US" sz="1050" dirty="0"/>
-          </a:p>
-        </p:txBody>
-      </p:sp>
-      <p:sp>
-        <p:nvSpPr>
-          <p:cNvPr id="14" name="Text 11"/>
-          <p:cNvSpPr/>
-          <p:nvPr/>
-        </p:nvSpPr>
-        <p:spPr>
-          <a:xfrm>
-            <a:off x="548640" y="5852160"/>
-            <a:ext cx="6309360" cy="365760"/>
-          </a:xfrm>
-          <a:prstGeom prst="rect">
-            <a:avLst/>
-          </a:prstGeom>
-          <a:noFill/>
-          <a:ln/>
-        </p:spPr>
-        <p:txBody>
-          <a:bodyPr wrap="square" lIns="0" tIns="0" rIns="0" bIns="0" rtlCol="0" anchor="ctr"/>
-          <a:lstStyle/>
-          <a:p>
-            <a:pPr indent="0" marL="0">
-              <a:buNone/>
-            </a:pPr>
-            <a:r>
-              <a:rPr lang="en-US" sz="1200" b="1" i="1" dirty="0">
-                <a:solidFill>
-                  <a:srgbClr val="1BAF7A"/>
-                </a:solidFill>
-                <a:latin typeface="Calibri" pitchFamily="34" charset="0"/>
-                <a:ea typeface="Calibri" pitchFamily="34" charset="-122"/>
-                <a:cs typeface="Calibri" pitchFamily="34" charset="-120"/>
-              </a:rPr>
-              <a:t>Axe le plus solide du projet.</a:t>
-            </a:r>
-            <a:endParaRPr lang="en-US" sz="1200" dirty="0"/>
-          </a:p>
-        </p:txBody>
-      </p:sp>
-      <p:sp>
-        <p:nvSpPr>
-          <p:cNvPr id="15" name="Text 12"/>
-          <p:cNvSpPr/>
-          <p:nvPr/>
-        </p:nvSpPr>
-        <p:spPr>
-          <a:xfrm>
-            <a:off x="548640" y="6510528"/>
-            <a:ext cx="5486400" cy="274320"/>
-          </a:xfrm>
-          <a:prstGeom prst="rect">
-            <a:avLst/>
-          </a:prstGeom>
-          <a:noFill/>
-          <a:ln/>
-        </p:spPr>
-        <p:txBody>
-          <a:bodyPr wrap="square" lIns="0" tIns="0" rIns="0" bIns="0" rtlCol="0" anchor="ctr"/>
-          <a:lstStyle/>
-          <a:p>
-            <a:pPr indent="0" marL="0">
-              <a:buNone/>
-            </a:pPr>
-            <a:r>
-              <a:rPr lang="en-US" sz="900" dirty="0">
-                <a:solidFill>
-                  <a:srgbClr val="9A9A95"/>
-                </a:solidFill>
-                <a:latin typeface="Calibri" pitchFamily="34" charset="0"/>
-                <a:ea typeface="Calibri" pitchFamily="34" charset="-122"/>
-                <a:cs typeface="Calibri" pitchFamily="34" charset="-120"/>
-              </a:rPr>
-              <a:t>Copilote Financier — Groupe Angelotti</a:t>
-            </a:r>
-            <a:endParaRPr lang="en-US" sz="900" dirty="0"/>
-          </a:p>
-        </p:txBody>
-      </p:sp>
-      <p:sp>
-        <p:nvSpPr>
-          <p:cNvPr id="16" name="Text 13"/>
-          <p:cNvSpPr/>
-          <p:nvPr/>
-        </p:nvSpPr>
-        <p:spPr>
-          <a:xfrm>
-            <a:off x="11430000" y="6510528"/>
-            <a:ext cx="365760" cy="274320"/>
-          </a:xfrm>
-          <a:prstGeom prst="rect">
-            <a:avLst/>
-          </a:prstGeom>
-          <a:noFill/>
-          <a:ln/>
-        </p:spPr>
-        <p:txBody>
-          <a:bodyPr wrap="square" lIns="0" tIns="0" rIns="0" bIns="0" rtlCol="0" anchor="ctr"/>
-          <a:lstStyle/>
-          <a:p>
-            <a:pPr algn="r" indent="0" marL="0">
-              <a:buNone/>
-            </a:pPr>
-            <a:r>
-              <a:rPr lang="en-US" sz="900" dirty="0">
-                <a:solidFill>
-                  <a:srgbClr val="9A9A95"/>
-                </a:solidFill>
-                <a:latin typeface="Calibri" pitchFamily="34" charset="0"/>
-                <a:ea typeface="Calibri" pitchFamily="34" charset="-122"/>
-                <a:cs typeface="Calibri" pitchFamily="34" charset="-120"/>
-              </a:rPr>
               <a:t>12</a:t>
             </a:r>
             <a:endParaRPr lang="en-US" sz="900" dirty="0"/>
@@ -5146,13 +5251,13 @@
             <a:r>
               <a:rPr lang="en-US" sz="1200" b="1" spc="200" kern="0" dirty="0">
                 <a:solidFill>
-                  <a:srgbClr val="4A3AA7"/>
-                </a:solidFill>
-                <a:latin typeface="Calibri" pitchFamily="34" charset="0"/>
-                <a:ea typeface="Calibri" pitchFamily="34" charset="-122"/>
-                <a:cs typeface="Calibri" pitchFamily="34" charset="-120"/>
-              </a:rPr>
-              <a:t>COPILOTE FINANCIER — AXE C</a:t>
+                  <a:srgbClr val="1BAF7A"/>
+                </a:solidFill>
+                <a:latin typeface="Calibri" pitchFamily="34" charset="0"/>
+                <a:ea typeface="Calibri" pitchFamily="34" charset="-122"/>
+                <a:cs typeface="Calibri" pitchFamily="34" charset="-120"/>
+              </a:rPr>
+              <a:t>COPILOTE FINANCIER — AXE B</a:t>
             </a:r>
             <a:endParaRPr lang="en-US" sz="1200" dirty="0"/>
           </a:p>
@@ -5167,7 +5272,7 @@
         <p:spPr>
           <a:xfrm>
             <a:off x="548640" y="658368"/>
-            <a:ext cx="10058400" cy="822960"/>
+            <a:ext cx="7315200" cy="822960"/>
           </a:xfrm>
           <a:prstGeom prst="rect">
             <a:avLst/>
@@ -5191,7 +5296,7 @@
                 <a:ea typeface="Cambria" pitchFamily="34" charset="-122"/>
                 <a:cs typeface="Cambria" pitchFamily="34" charset="-120"/>
               </a:rPr>
-              <a:t>L'optimisation des prix</a:t>
+              <a:t>La vitesse d'écoulement</a:t>
             </a:r>
             <a:endParaRPr lang="en-US" sz="2800" dirty="0"/>
           </a:p>
@@ -5205,8 +5310,8 @@
         </p:nvSpPr>
         <p:spPr>
           <a:xfrm>
-            <a:off x="548640" y="1691640"/>
-            <a:ext cx="6492240" cy="4572000"/>
+            <a:off x="548640" y="1600200"/>
+            <a:ext cx="6309360" cy="3108960"/>
           </a:xfrm>
           <a:prstGeom prst="rect">
             <a:avLst/>
@@ -5223,13 +5328,13 @@
                 <a:spcPct val="106000"/>
               </a:lnSpc>
               <a:spcAft>
-                <a:spcPts val="1200"/>
+                <a:spcPts val="1300"/>
               </a:spcAft>
               <a:buSzPct val="100000"/>
               <a:buChar char="•"/>
             </a:pPr>
             <a:r>
-              <a:rPr lang="en-US" sz="1300" dirty="0">
+              <a:rPr lang="en-US" sz="1400" dirty="0">
                 <a:solidFill>
                   <a:srgbClr val="1A1A19"/>
                 </a:solidFill>
@@ -5237,9 +5342,9 @@
                 <a:ea typeface="Calibri" pitchFamily="34" charset="-122"/>
                 <a:cs typeface="Calibri" pitchFamily="34" charset="-120"/>
               </a:rPr>
-              <a:t>Modèle hédonique sur 5 064 appartements vendus depuis 2016 — primes cohérentes (étage +6,0 %, sud +2,6 %, social −62,8 %, millésime +19-21 %)</a:t>
-            </a:r>
-            <a:endParaRPr lang="en-US" sz="1300" dirty="0"/>
+              <a:t>Panel de 3 230 observations (opération × mois) — modèle à effets aléatoires</a:t>
+            </a:r>
+            <a:endParaRPr lang="en-US" sz="1400" dirty="0"/>
           </a:p>
           <a:p>
             <a:pPr marL="203200" indent="-203200">
@@ -5247,13 +5352,13 @@
                 <a:spcPct val="106000"/>
               </a:lnSpc>
               <a:spcAft>
-                <a:spcPts val="1200"/>
+                <a:spcPts val="1300"/>
               </a:spcAft>
               <a:buSzPct val="100000"/>
               <a:buChar char="•"/>
             </a:pPr>
             <a:r>
-              <a:rPr lang="en-US" sz="1300" dirty="0">
+              <a:rPr lang="en-US" sz="1400" dirty="0">
                 <a:solidFill>
                   <a:srgbClr val="1A1A19"/>
                 </a:solidFill>
@@ -5261,9 +5366,9 @@
                 <a:ea typeface="Calibri" pitchFamily="34" charset="-122"/>
                 <a:cs typeface="Calibri" pitchFamily="34" charset="-120"/>
               </a:rPr>
-              <a:t>Élasticité non significative en interne (p = 0,57) → fixée prudemment à −1, documentée plutôt que masquée</a:t>
-            </a:r>
-            <a:endParaRPr lang="en-US" sz="1300" dirty="0"/>
+              <a:t>2/3 de la variance = effet propre à l'opération, 1/3 = conjoncture</a:t>
+            </a:r>
+            <a:endParaRPr lang="en-US" sz="1400" dirty="0"/>
           </a:p>
           <a:p>
             <a:pPr marL="203200" indent="-203200">
@@ -5271,13 +5376,13 @@
                 <a:spcPct val="106000"/>
               </a:lnSpc>
               <a:spcAft>
-                <a:spcPts val="1200"/>
+                <a:spcPts val="1300"/>
               </a:spcAft>
               <a:buSzPct val="100000"/>
               <a:buChar char="•"/>
             </a:pPr>
             <a:r>
-              <a:rPr lang="en-US" sz="1300" dirty="0">
+              <a:rPr lang="en-US" sz="1400" dirty="0">
                 <a:solidFill>
                   <a:srgbClr val="1A1A19"/>
                 </a:solidFill>
@@ -5285,33 +5390,9 @@
                 <a:ea typeface="Calibri" pitchFamily="34" charset="-122"/>
                 <a:cs typeface="Calibri" pitchFamily="34" charset="-120"/>
               </a:rPr>
-              <a:t>Optimisation par multiplicateur de Lagrange, vérifiée par un second solveur indépendant (SLSQP) — convergence à 0,006 près</a:t>
-            </a:r>
-            <a:endParaRPr lang="en-US" sz="1300" dirty="0"/>
-          </a:p>
-          <a:p>
-            <a:pPr marL="203200" indent="-203200">
-              <a:lnSpc>
-                <a:spcPct val="106000"/>
-              </a:lnSpc>
-              <a:spcAft>
-                <a:spcPts val="1200"/>
-              </a:spcAft>
-              <a:buSzPct val="100000"/>
-              <a:buChar char="•"/>
-            </a:pPr>
-            <a:r>
-              <a:rPr lang="en-US" sz="1300" dirty="0">
-                <a:solidFill>
-                  <a:srgbClr val="1A1A19"/>
-                </a:solidFill>
-                <a:latin typeface="Calibri" pitchFamily="34" charset="0"/>
-                <a:ea typeface="Calibri" pitchFamily="34" charset="-122"/>
-                <a:cs typeface="Calibri" pitchFamily="34" charset="-120"/>
-              </a:rPr>
-              <a:t>Résultat contre-intuitif : remise optimale identique en euros sur tous les lots — ex. Arpeggio (18 lots), ajustements de −5 % à −14 % selon le prix</a:t>
-            </a:r>
-            <a:endParaRPr lang="en-US" sz="1300" dirty="0"/>
+              <a:t>Contrôle par série temporelle : effet du taux non identifiable isolément — validation méthodologique, pas un échec</a:t>
+            </a:r>
+            <a:endParaRPr lang="en-US" sz="1400" dirty="0"/>
           </a:p>
         </p:txBody>
       </p:sp>
@@ -5323,12 +5404,108 @@
         </p:nvSpPr>
         <p:spPr>
           <a:xfrm>
-            <a:off x="7315200" y="1691640"/>
-            <a:ext cx="4297680" cy="1371600"/>
+            <a:off x="7013448" y="1618488"/>
+            <a:ext cx="4672584" cy="1956816"/>
           </a:xfrm>
           <a:prstGeom prst="roundRect">
             <a:avLst>
-              <a:gd name="adj" fmla="val 5333"/>
+              <a:gd name="adj" fmla="val 2804"/>
+            </a:avLst>
+          </a:prstGeom>
+          <a:solidFill>
+            <a:srgbClr val="FFFFFF"/>
+          </a:solidFill>
+          <a:ln w="12700">
+            <a:solidFill>
+              <a:srgbClr val="E3E7EE"/>
+            </a:solidFill>
+            <a:prstDash val="solid"/>
+          </a:ln>
+          <a:effectLst>
+            <a:outerShdw sx="100000" sy="100000" kx="0" ky="0" algn="bl" rotWithShape="0" blurRad="101600" dist="25400" dir="5400000">
+              <a:srgbClr val="1A1A19">
+                <a:alpha val="15000"/>
+              </a:srgbClr>
+            </a:outerShdw>
+          </a:effectLst>
+        </p:spPr>
+      </p:sp>
+      <p:pic>
+        <p:nvPicPr>
+          <p:cNvPr id="6" name="Image 0" descr="/tmp/claude-0/-home-user-MemoireM2S2/bac073a6-7c4e-552a-9627-815aeb6fe82a/scratchpad/figs/p28-000.png">    </p:cNvPr>
+          <p:cNvPicPr>
+            <a:picLocks noChangeAspect="1"/>
+          </p:cNvPicPr>
+          <p:nvPr/>
+        </p:nvPicPr>
+        <p:blipFill>
+          <a:blip r:embed="rId1"/>
+          <a:srcRect l="0" r="0" t="0" b="0"/>
+          <a:stretch/>
+        </p:blipFill>
+        <p:spPr>
+          <a:xfrm>
+            <a:off x="7086600" y="1691640"/>
+            <a:ext cx="4526280" cy="1810512"/>
+          </a:xfrm>
+          <a:prstGeom prst="rect">
+            <a:avLst/>
+          </a:prstGeom>
+        </p:spPr>
+      </p:pic>
+      <p:sp>
+        <p:nvSpPr>
+          <p:cNvPr id="7" name="Text 4"/>
+          <p:cNvSpPr/>
+          <p:nvPr/>
+        </p:nvSpPr>
+        <p:spPr>
+          <a:xfrm>
+            <a:off x="7086600" y="3529584"/>
+            <a:ext cx="4526280" cy="411480"/>
+          </a:xfrm>
+          <a:prstGeom prst="rect">
+            <a:avLst/>
+          </a:prstGeom>
+          <a:noFill/>
+          <a:ln/>
+        </p:spPr>
+        <p:txBody>
+          <a:bodyPr wrap="square" lIns="0" tIns="0" rIns="0" bIns="0" rtlCol="0" anchor="ctr"/>
+          <a:lstStyle/>
+          <a:p>
+            <a:pPr indent="0" marL="0">
+              <a:buNone/>
+            </a:pPr>
+            <a:r>
+              <a:rPr lang="en-US" sz="950" i="1" dirty="0">
+                <a:solidFill>
+                  <a:srgbClr val="52514E"/>
+                </a:solidFill>
+                <a:latin typeface="Calibri" pitchFamily="34" charset="0"/>
+                <a:ea typeface="Calibri" pitchFamily="34" charset="-122"/>
+                <a:cs typeface="Calibri" pitchFamily="34" charset="-120"/>
+              </a:rPr>
+              <a:t>Fig. — Scénarios de taux 2026 : trajectoire ARIMA combinée à l'élasticité du panel</a:t>
+            </a:r>
+            <a:endParaRPr lang="en-US" sz="950" dirty="0"/>
+          </a:p>
+        </p:txBody>
+      </p:sp>
+      <p:sp>
+        <p:nvSpPr>
+          <p:cNvPr id="8" name="Shape 5"/>
+          <p:cNvSpPr/>
+          <p:nvPr/>
+        </p:nvSpPr>
+        <p:spPr>
+          <a:xfrm>
+            <a:off x="7086600" y="4251960"/>
+            <a:ext cx="2148840" cy="1417320"/>
+          </a:xfrm>
+          <a:prstGeom prst="roundRect">
+            <a:avLst>
+              <a:gd name="adj" fmla="val 5161"/>
             </a:avLst>
           </a:prstGeom>
           <a:solidFill>
@@ -5351,14 +5528,14 @@
       </p:sp>
       <p:sp>
         <p:nvSpPr>
-          <p:cNvPr id="6" name="Text 4"/>
-          <p:cNvSpPr/>
-          <p:nvPr/>
-        </p:nvSpPr>
-        <p:spPr>
-          <a:xfrm>
-            <a:off x="7424928" y="1764792"/>
-            <a:ext cx="4078224" cy="822960"/>
+          <p:cNvPr id="9" name="Text 6"/>
+          <p:cNvSpPr/>
+          <p:nvPr/>
+        </p:nvSpPr>
+        <p:spPr>
+          <a:xfrm>
+            <a:off x="7196328" y="4325112"/>
+            <a:ext cx="1929384" cy="868680"/>
           </a:xfrm>
           <a:prstGeom prst="rect">
             <a:avLst/>
@@ -5376,13 +5553,13 @@
             <a:r>
               <a:rPr lang="en-US" sz="2800" b="1" dirty="0">
                 <a:solidFill>
-                  <a:srgbClr val="4A3AA7"/>
+                  <a:srgbClr val="1BAF7A"/>
                 </a:solidFill>
                 <a:latin typeface="Cambria" pitchFamily="34" charset="0"/>
                 <a:ea typeface="Cambria" pitchFamily="34" charset="-122"/>
                 <a:cs typeface="Cambria" pitchFamily="34" charset="-120"/>
               </a:rPr>
-              <a:t>R² = 0,886</a:t>
+              <a:t>−19 %</a:t>
             </a:r>
             <a:endParaRPr lang="en-US" sz="2800" dirty="0"/>
           </a:p>
@@ -5390,14 +5567,14 @@
       </p:sp>
       <p:sp>
         <p:nvSpPr>
-          <p:cNvPr id="7" name="Text 5"/>
-          <p:cNvSpPr/>
-          <p:nvPr/>
-        </p:nvSpPr>
-        <p:spPr>
-          <a:xfrm>
-            <a:off x="7424928" y="2624328"/>
-            <a:ext cx="4078224" cy="384048"/>
+          <p:cNvPr id="10" name="Text 7"/>
+          <p:cNvSpPr/>
+          <p:nvPr/>
+        </p:nvSpPr>
+        <p:spPr>
+          <a:xfrm>
+            <a:off x="7196328" y="5230368"/>
+            <a:ext cx="1929384" cy="384048"/>
           </a:xfrm>
           <a:prstGeom prst="rect">
             <a:avLst/>
@@ -5421,7 +5598,7 @@
                 <a:ea typeface="Calibri" pitchFamily="34" charset="-122"/>
                 <a:cs typeface="Calibri" pitchFamily="34" charset="-120"/>
               </a:rPr>
-              <a:t>variance du prix expliquée, erreur type ≈ 11 %</a:t>
+              <a:t>de réservations par point de taux en plus</a:t>
             </a:r>
             <a:endParaRPr lang="en-US" sz="1050" dirty="0"/>
           </a:p>
@@ -5429,18 +5606,18 @@
       </p:sp>
       <p:sp>
         <p:nvSpPr>
-          <p:cNvPr id="8" name="Shape 6"/>
-          <p:cNvSpPr/>
-          <p:nvPr/>
-        </p:nvSpPr>
-        <p:spPr>
-          <a:xfrm>
-            <a:off x="7315200" y="3246120"/>
-            <a:ext cx="4297680" cy="1371600"/>
+          <p:cNvPr id="11" name="Shape 8"/>
+          <p:cNvSpPr/>
+          <p:nvPr/>
+        </p:nvSpPr>
+        <p:spPr>
+          <a:xfrm>
+            <a:off x="9464040" y="4251960"/>
+            <a:ext cx="2148840" cy="1417320"/>
           </a:xfrm>
           <a:prstGeom prst="roundRect">
             <a:avLst>
-              <a:gd name="adj" fmla="val 5333"/>
+              <a:gd name="adj" fmla="val 5161"/>
             </a:avLst>
           </a:prstGeom>
           <a:solidFill>
@@ -5463,14 +5640,14 @@
       </p:sp>
       <p:sp>
         <p:nvSpPr>
-          <p:cNvPr id="9" name="Text 7"/>
-          <p:cNvSpPr/>
-          <p:nvPr/>
-        </p:nvSpPr>
-        <p:spPr>
-          <a:xfrm>
-            <a:off x="7424928" y="3319272"/>
-            <a:ext cx="4078224" cy="822960"/>
+          <p:cNvPr id="12" name="Text 9"/>
+          <p:cNvSpPr/>
+          <p:nvPr/>
+        </p:nvSpPr>
+        <p:spPr>
+          <a:xfrm>
+            <a:off x="9573768" y="4325112"/>
+            <a:ext cx="1929384" cy="868680"/>
           </a:xfrm>
           <a:prstGeom prst="rect">
             <a:avLst/>
@@ -5488,13 +5665,13 @@
             <a:r>
               <a:rPr lang="en-US" sz="2800" b="1" dirty="0">
                 <a:solidFill>
-                  <a:srgbClr val="EDA100"/>
+                  <a:srgbClr val="2A78D6"/>
                 </a:solidFill>
                 <a:latin typeface="Cambria" pitchFamily="34" charset="0"/>
                 <a:ea typeface="Cambria" pitchFamily="34" charset="-122"/>
                 <a:cs typeface="Cambria" pitchFamily="34" charset="-120"/>
               </a:rPr>
-              <a:t>24 / 127</a:t>
+              <a:t>20 mois</a:t>
             </a:r>
             <a:endParaRPr lang="en-US" sz="2800" dirty="0"/>
           </a:p>
@@ -5502,14 +5679,14 @@
       </p:sp>
       <p:sp>
         <p:nvSpPr>
-          <p:cNvPr id="10" name="Text 8"/>
-          <p:cNvSpPr/>
-          <p:nvPr/>
-        </p:nvSpPr>
-        <p:spPr>
-          <a:xfrm>
-            <a:off x="7424928" y="4178808"/>
-            <a:ext cx="4078224" cy="384048"/>
+          <p:cNvPr id="13" name="Text 10"/>
+          <p:cNvSpPr/>
+          <p:nvPr/>
+        </p:nvSpPr>
+        <p:spPr>
+          <a:xfrm>
+            <a:off x="9573768" y="5230368"/>
+            <a:ext cx="1929384" cy="384048"/>
           </a:xfrm>
           <a:prstGeom prst="rect">
             <a:avLst/>
@@ -5533,7 +5710,7 @@
                 <a:ea typeface="Calibri" pitchFamily="34" charset="-122"/>
                 <a:cs typeface="Calibri" pitchFamily="34" charset="-120"/>
               </a:rPr>
-              <a:t>lots du stock signalés hors marché</a:t>
+              <a:t>délai médian pour 90 % du potentiel vendu</a:t>
             </a:r>
             <a:endParaRPr lang="en-US" sz="1050" dirty="0"/>
           </a:p>
@@ -5541,119 +5718,46 @@
       </p:sp>
       <p:sp>
         <p:nvSpPr>
-          <p:cNvPr id="11" name="Shape 9"/>
-          <p:cNvSpPr/>
-          <p:nvPr/>
-        </p:nvSpPr>
-        <p:spPr>
-          <a:xfrm>
-            <a:off x="7315200" y="4800600"/>
-            <a:ext cx="4297680" cy="1371600"/>
-          </a:xfrm>
-          <a:prstGeom prst="roundRect">
-            <a:avLst>
-              <a:gd name="adj" fmla="val 5333"/>
-            </a:avLst>
-          </a:prstGeom>
-          <a:solidFill>
-            <a:srgbClr val="FFFFFF"/>
-          </a:solidFill>
-          <a:ln w="12700">
-            <a:solidFill>
-              <a:srgbClr val="E3E7EE"/>
-            </a:solidFill>
-            <a:prstDash val="solid"/>
-          </a:ln>
-          <a:effectLst>
-            <a:outerShdw sx="100000" sy="100000" kx="0" ky="0" algn="bl" rotWithShape="0" blurRad="76200" dist="25400" dir="5400000">
-              <a:srgbClr val="1A1A19">
-                <a:alpha val="12000"/>
-              </a:srgbClr>
-            </a:outerShdw>
-          </a:effectLst>
-        </p:spPr>
-      </p:sp>
-      <p:sp>
-        <p:nvSpPr>
-          <p:cNvPr id="12" name="Text 10"/>
-          <p:cNvSpPr/>
-          <p:nvPr/>
-        </p:nvSpPr>
-        <p:spPr>
-          <a:xfrm>
-            <a:off x="7424928" y="4873752"/>
-            <a:ext cx="4078224" cy="822960"/>
-          </a:xfrm>
-          <a:prstGeom prst="rect">
-            <a:avLst/>
-          </a:prstGeom>
-          <a:noFill/>
-          <a:ln/>
-        </p:spPr>
-        <p:txBody>
-          <a:bodyPr wrap="square" lIns="0" tIns="0" rIns="0" bIns="0" rtlCol="0" anchor="b"/>
-          <a:lstStyle/>
-          <a:p>
-            <a:pPr algn="l" indent="0" marL="0">
-              <a:buNone/>
-            </a:pPr>
-            <a:r>
-              <a:rPr lang="en-US" sz="2800" b="1" dirty="0">
-                <a:solidFill>
-                  <a:srgbClr val="2A78D6"/>
-                </a:solidFill>
-                <a:latin typeface="Cambria" pitchFamily="34" charset="0"/>
-                <a:ea typeface="Cambria" pitchFamily="34" charset="-122"/>
-                <a:cs typeface="Cambria" pitchFamily="34" charset="-120"/>
-              </a:rPr>
-              <a:t>0,006</a:t>
-            </a:r>
-            <a:endParaRPr lang="en-US" sz="2800" dirty="0"/>
-          </a:p>
-        </p:txBody>
-      </p:sp>
-      <p:sp>
-        <p:nvSpPr>
-          <p:cNvPr id="13" name="Text 11"/>
-          <p:cNvSpPr/>
-          <p:nvPr/>
-        </p:nvSpPr>
-        <p:spPr>
-          <a:xfrm>
-            <a:off x="7424928" y="5733288"/>
-            <a:ext cx="4078224" cy="384048"/>
-          </a:xfrm>
-          <a:prstGeom prst="rect">
-            <a:avLst/>
-          </a:prstGeom>
-          <a:noFill/>
-          <a:ln/>
-        </p:spPr>
-        <p:txBody>
-          <a:bodyPr wrap="square" lIns="0" tIns="0" rIns="0" bIns="0" rtlCol="0" anchor="t"/>
-          <a:lstStyle/>
-          <a:p>
-            <a:pPr algn="l" indent="0" marL="0">
-              <a:buNone/>
-            </a:pPr>
-            <a:r>
-              <a:rPr lang="en-US" sz="1050" dirty="0">
-                <a:solidFill>
-                  <a:srgbClr val="52514E"/>
-                </a:solidFill>
-                <a:latin typeface="Calibri" pitchFamily="34" charset="0"/>
-                <a:ea typeface="Calibri" pitchFamily="34" charset="-122"/>
-                <a:cs typeface="Calibri" pitchFamily="34" charset="-120"/>
-              </a:rPr>
-              <a:t>écart entre les deux solveurs d'optimisation</a:t>
-            </a:r>
-            <a:endParaRPr lang="en-US" sz="1050" dirty="0"/>
-          </a:p>
-        </p:txBody>
-      </p:sp>
-      <p:sp>
-        <p:nvSpPr>
-          <p:cNvPr id="14" name="Text 12"/>
+          <p:cNvPr id="14" name="Text 11"/>
+          <p:cNvSpPr/>
+          <p:nvPr/>
+        </p:nvSpPr>
+        <p:spPr>
+          <a:xfrm>
+            <a:off x="548640" y="5852160"/>
+            <a:ext cx="6309360" cy="365760"/>
+          </a:xfrm>
+          <a:prstGeom prst="rect">
+            <a:avLst/>
+          </a:prstGeom>
+          <a:noFill/>
+          <a:ln/>
+        </p:spPr>
+        <p:txBody>
+          <a:bodyPr wrap="square" lIns="0" tIns="0" rIns="0" bIns="0" rtlCol="0" anchor="ctr"/>
+          <a:lstStyle/>
+          <a:p>
+            <a:pPr indent="0" marL="0">
+              <a:buNone/>
+            </a:pPr>
+            <a:r>
+              <a:rPr lang="en-US" sz="1200" b="1" i="1" dirty="0">
+                <a:solidFill>
+                  <a:srgbClr val="1BAF7A"/>
+                </a:solidFill>
+                <a:latin typeface="Calibri" pitchFamily="34" charset="0"/>
+                <a:ea typeface="Calibri" pitchFamily="34" charset="-122"/>
+                <a:cs typeface="Calibri" pitchFamily="34" charset="-120"/>
+              </a:rPr>
+              <a:t>Axe le plus solide du projet.</a:t>
+            </a:r>
+            <a:endParaRPr lang="en-US" sz="1200" dirty="0"/>
+          </a:p>
+        </p:txBody>
+      </p:sp>
+      <p:sp>
+        <p:nvSpPr>
+          <p:cNvPr id="15" name="Text 12"/>
           <p:cNvSpPr/>
           <p:nvPr/>
         </p:nvSpPr>
@@ -5692,7 +5796,7 @@
       </p:sp>
       <p:sp>
         <p:nvSpPr>
-          <p:cNvPr id="15" name="Text 13"/>
+          <p:cNvPr id="16" name="Text 13"/>
           <p:cNvSpPr/>
           <p:nvPr/>
         </p:nvSpPr>
@@ -5788,13 +5892,13 @@
             <a:r>
               <a:rPr lang="en-US" sz="1200" b="1" spc="200" kern="0" dirty="0">
                 <a:solidFill>
-                  <a:srgbClr val="EDA100"/>
-                </a:solidFill>
-                <a:latin typeface="Calibri" pitchFamily="34" charset="0"/>
-                <a:ea typeface="Calibri" pitchFamily="34" charset="-122"/>
-                <a:cs typeface="Calibri" pitchFamily="34" charset="-120"/>
-              </a:rPr>
-              <a:t>COPILOTE FINANCIER — AXE TRANSVERSE</a:t>
+                  <a:srgbClr val="4A3AA7"/>
+                </a:solidFill>
+                <a:latin typeface="Calibri" pitchFamily="34" charset="0"/>
+                <a:ea typeface="Calibri" pitchFamily="34" charset="-122"/>
+                <a:cs typeface="Calibri" pitchFamily="34" charset="-120"/>
+              </a:rPr>
+              <a:t>COPILOTE FINANCIER — AXE C</a:t>
             </a:r>
             <a:endParaRPr lang="en-US" sz="1200" dirty="0"/>
           </a:p>
@@ -5809,7 +5913,7 @@
         <p:spPr>
           <a:xfrm>
             <a:off x="548640" y="658368"/>
-            <a:ext cx="10515600" cy="822960"/>
+            <a:ext cx="10058400" cy="822960"/>
           </a:xfrm>
           <a:prstGeom prst="rect">
             <a:avLst/>
@@ -5833,7 +5937,7 @@
                 <a:ea typeface="Cambria" pitchFamily="34" charset="-122"/>
                 <a:cs typeface="Cambria" pitchFamily="34" charset="-120"/>
               </a:rPr>
-              <a:t>Signaux faibles : texte et réseau de vente</a:t>
+              <a:t>L'optimisation des prix</a:t>
             </a:r>
             <a:endParaRPr lang="en-US" sz="2800" dirty="0"/>
           </a:p>
@@ -5847,8 +5951,8 @@
         </p:nvSpPr>
         <p:spPr>
           <a:xfrm>
-            <a:off x="548640" y="1600200"/>
-            <a:ext cx="6583680" cy="4663440"/>
+            <a:off x="548640" y="1691640"/>
+            <a:ext cx="6492240" cy="4572000"/>
           </a:xfrm>
           <a:prstGeom prst="rect">
             <a:avLst/>
@@ -5865,7 +5969,7 @@
                 <a:spcPct val="106000"/>
               </a:lnSpc>
               <a:spcAft>
-                <a:spcPts val="1300"/>
+                <a:spcPts val="1200"/>
               </a:spcAft>
               <a:buSzPct val="100000"/>
               <a:buChar char="•"/>
@@ -5879,7 +5983,7 @@
                 <a:ea typeface="Calibri" pitchFamily="34" charset="-122"/>
                 <a:cs typeface="Calibri" pitchFamily="34" charset="-120"/>
               </a:rPr>
-              <a:t>9 688 commentaires libres de vente : moteur de recherche par similarité (TF-IDF + cosinus, corpus de 1 346 documents)</a:t>
+              <a:t>Modèle hédonique sur 5 064 appartements vendus depuis 2016 — primes cohérentes (étage +6,0 %, sud +2,6 %, social −62,8 %, millésime +19-21 %)</a:t>
             </a:r>
             <a:endParaRPr lang="en-US" sz="1300" dirty="0"/>
           </a:p>
@@ -5889,7 +5993,7 @@
                 <a:spcPct val="106000"/>
               </a:lnSpc>
               <a:spcAft>
-                <a:spcPts val="1300"/>
+                <a:spcPts val="1200"/>
               </a:spcAft>
               <a:buSzPct val="100000"/>
               <a:buChar char="•"/>
@@ -5903,7 +6007,7 @@
                 <a:ea typeface="Calibri" pitchFamily="34" charset="-122"/>
                 <a:cs typeface="Calibri" pitchFamily="34" charset="-120"/>
               </a:rPr>
-              <a:t>Prédiction du désistement par le texte, fuite contrôlée (314 commentaires écartés) : Naive Bayes F1 = 0,343, préféré à une régression logistique quasi muette</a:t>
+              <a:t>Élasticité non significative en interne (p = 0,57) → fixée prudemment à −1, documentée plutôt que masquée</a:t>
             </a:r>
             <a:endParaRPr lang="en-US" sz="1300" dirty="0"/>
           </a:p>
@@ -5913,7 +6017,7 @@
                 <a:spcPct val="106000"/>
               </a:lnSpc>
               <a:spcAft>
-                <a:spcPts val="1300"/>
+                <a:spcPts val="1200"/>
               </a:spcAft>
               <a:buSzPct val="100000"/>
               <a:buChar char="•"/>
@@ -5927,7 +6031,7 @@
                 <a:ea typeface="Calibri" pitchFamily="34" charset="-122"/>
                 <a:cs typeface="Calibri" pitchFamily="34" charset="-120"/>
               </a:rPr>
-              <a:t>Divergence de Kullback-Leibler (écart entre distributions) : révèle un défaut de saisie sur une agence (90 % de motifs « autres »), pas un profil client</a:t>
+              <a:t>Optimisation par multiplicateur de Lagrange, vérifiée par un second solveur indépendant (SLSQP) — convergence à 0,006 près</a:t>
             </a:r>
             <a:endParaRPr lang="en-US" sz="1300" dirty="0"/>
           </a:p>
@@ -5937,7 +6041,7 @@
                 <a:spcPct val="106000"/>
               </a:lnSpc>
               <a:spcAft>
-                <a:spcPts val="1300"/>
+                <a:spcPts val="1200"/>
               </a:spcAft>
               <a:buSzPct val="100000"/>
               <a:buChar char="•"/>
@@ -5951,7 +6055,7 @@
                 <a:ea typeface="Calibri" pitchFamily="34" charset="-122"/>
                 <a:cs typeface="Calibri" pitchFamily="34" charset="-120"/>
               </a:rPr>
-              <a:t>Réseau biparti vendeurs-opérations (209 vendeurs, 711 arêtes) : deux pivots concentrent 51,6 % des dossiers, désistement très contrasté (9,0 % vs 29,6 %)</a:t>
+              <a:t>Résultat contre-intuitif : remise optimale identique en euros sur tous les lots — ex. Arpeggio (18 lots), ajustements de −5 % à −14 % selon le prix</a:t>
             </a:r>
             <a:endParaRPr lang="en-US" sz="1300" dirty="0"/>
           </a:p>
@@ -5965,8 +6069,8 @@
         </p:nvSpPr>
         <p:spPr>
           <a:xfrm>
-            <a:off x="7360920" y="1691640"/>
-            <a:ext cx="4251960" cy="1371600"/>
+            <a:off x="7315200" y="1691640"/>
+            <a:ext cx="4297680" cy="1371600"/>
           </a:xfrm>
           <a:prstGeom prst="roundRect">
             <a:avLst>
@@ -5999,8 +6103,8 @@
         </p:nvSpPr>
         <p:spPr>
           <a:xfrm>
-            <a:off x="7470648" y="1764792"/>
-            <a:ext cx="4032504" cy="822960"/>
+            <a:off x="7424928" y="1764792"/>
+            <a:ext cx="4078224" cy="822960"/>
           </a:xfrm>
           <a:prstGeom prst="rect">
             <a:avLst/>
@@ -6018,13 +6122,13 @@
             <a:r>
               <a:rPr lang="en-US" sz="2800" b="1" dirty="0">
                 <a:solidFill>
-                  <a:srgbClr val="EDA100"/>
+                  <a:srgbClr val="4A3AA7"/>
                 </a:solidFill>
                 <a:latin typeface="Cambria" pitchFamily="34" charset="0"/>
                 <a:ea typeface="Cambria" pitchFamily="34" charset="-122"/>
                 <a:cs typeface="Cambria" pitchFamily="34" charset="-120"/>
               </a:rPr>
-              <a:t>F1 = 0,343</a:t>
+              <a:t>R² = 0,886</a:t>
             </a:r>
             <a:endParaRPr lang="en-US" sz="2800" dirty="0"/>
           </a:p>
@@ -6038,8 +6142,8 @@
         </p:nvSpPr>
         <p:spPr>
           <a:xfrm>
-            <a:off x="7470648" y="2624328"/>
-            <a:ext cx="4032504" cy="384048"/>
+            <a:off x="7424928" y="2624328"/>
+            <a:ext cx="4078224" cy="384048"/>
           </a:xfrm>
           <a:prstGeom prst="rect">
             <a:avLst/>
@@ -6063,7 +6167,7 @@
                 <a:ea typeface="Calibri" pitchFamily="34" charset="-122"/>
                 <a:cs typeface="Calibri" pitchFamily="34" charset="-120"/>
               </a:rPr>
-              <a:t>Naive Bayes, désistement prédit par le texte</a:t>
+              <a:t>variance du prix expliquée, erreur type ≈ 11 %</a:t>
             </a:r>
             <a:endParaRPr lang="en-US" sz="1050" dirty="0"/>
           </a:p>
@@ -6077,8 +6181,8 @@
         </p:nvSpPr>
         <p:spPr>
           <a:xfrm>
-            <a:off x="7360920" y="3246120"/>
-            <a:ext cx="4251960" cy="1371600"/>
+            <a:off x="7315200" y="3246120"/>
+            <a:ext cx="4297680" cy="1371600"/>
           </a:xfrm>
           <a:prstGeom prst="roundRect">
             <a:avLst>
@@ -6111,8 +6215,8 @@
         </p:nvSpPr>
         <p:spPr>
           <a:xfrm>
-            <a:off x="7470648" y="3319272"/>
-            <a:ext cx="4032504" cy="822960"/>
+            <a:off x="7424928" y="3319272"/>
+            <a:ext cx="4078224" cy="822960"/>
           </a:xfrm>
           <a:prstGeom prst="rect">
             <a:avLst/>
@@ -6130,13 +6234,13 @@
             <a:r>
               <a:rPr lang="en-US" sz="2800" b="1" dirty="0">
                 <a:solidFill>
-                  <a:srgbClr val="4A3AA7"/>
+                  <a:srgbClr val="EDA100"/>
                 </a:solidFill>
                 <a:latin typeface="Cambria" pitchFamily="34" charset="0"/>
                 <a:ea typeface="Cambria" pitchFamily="34" charset="-122"/>
                 <a:cs typeface="Cambria" pitchFamily="34" charset="-120"/>
               </a:rPr>
-              <a:t>51,6 %</a:t>
+              <a:t>24 / 127</a:t>
             </a:r>
             <a:endParaRPr lang="en-US" sz="2800" dirty="0"/>
           </a:p>
@@ -6150,8 +6254,8 @@
         </p:nvSpPr>
         <p:spPr>
           <a:xfrm>
-            <a:off x="7470648" y="4178808"/>
-            <a:ext cx="4032504" cy="384048"/>
+            <a:off x="7424928" y="4178808"/>
+            <a:ext cx="4078224" cy="384048"/>
           </a:xfrm>
           <a:prstGeom prst="rect">
             <a:avLst/>
@@ -6175,7 +6279,7 @@
                 <a:ea typeface="Calibri" pitchFamily="34" charset="-122"/>
                 <a:cs typeface="Calibri" pitchFamily="34" charset="-120"/>
               </a:rPr>
-              <a:t>des dossiers concentrés sur 2 vendeurs pivots</a:t>
+              <a:t>lots du stock signalés hors marché</a:t>
             </a:r>
             <a:endParaRPr lang="en-US" sz="1050" dirty="0"/>
           </a:p>
@@ -6189,8 +6293,8 @@
         </p:nvSpPr>
         <p:spPr>
           <a:xfrm>
-            <a:off x="7360920" y="4800600"/>
-            <a:ext cx="4251960" cy="1371600"/>
+            <a:off x="7315200" y="4800600"/>
+            <a:ext cx="4297680" cy="1371600"/>
           </a:xfrm>
           <a:prstGeom prst="roundRect">
             <a:avLst>
@@ -6223,8 +6327,8 @@
         </p:nvSpPr>
         <p:spPr>
           <a:xfrm>
-            <a:off x="7470648" y="4873752"/>
-            <a:ext cx="4032504" cy="822960"/>
+            <a:off x="7424928" y="4873752"/>
+            <a:ext cx="4078224" cy="822960"/>
           </a:xfrm>
           <a:prstGeom prst="rect">
             <a:avLst/>
@@ -6240,17 +6344,17 @@
               <a:buNone/>
             </a:pPr>
             <a:r>
-              <a:rPr lang="en-US" sz="2000" b="1" dirty="0">
-                <a:solidFill>
-                  <a:srgbClr val="E34948"/>
+              <a:rPr lang="en-US" sz="2800" b="1" dirty="0">
+                <a:solidFill>
+                  <a:srgbClr val="2A78D6"/>
                 </a:solidFill>
                 <a:latin typeface="Cambria" pitchFamily="34" charset="0"/>
                 <a:ea typeface="Cambria" pitchFamily="34" charset="-122"/>
                 <a:cs typeface="Cambria" pitchFamily="34" charset="-120"/>
               </a:rPr>
-              <a:t>9,0 % / 29,6 %</a:t>
-            </a:r>
-            <a:endParaRPr lang="en-US" sz="2000" dirty="0"/>
+              <a:t>0,006</a:t>
+            </a:r>
+            <a:endParaRPr lang="en-US" sz="2800" dirty="0"/>
           </a:p>
         </p:txBody>
       </p:sp>
@@ -6262,8 +6366,8 @@
         </p:nvSpPr>
         <p:spPr>
           <a:xfrm>
-            <a:off x="7470648" y="5733288"/>
-            <a:ext cx="4032504" cy="384048"/>
+            <a:off x="7424928" y="5733288"/>
+            <a:ext cx="4078224" cy="384048"/>
           </a:xfrm>
           <a:prstGeom prst="rect">
             <a:avLst/>
@@ -6287,7 +6391,7 @@
                 <a:ea typeface="Calibri" pitchFamily="34" charset="-122"/>
                 <a:cs typeface="Calibri" pitchFamily="34" charset="-120"/>
               </a:rPr>
-              <a:t>désistement : pivot interne vs prescripteur externe</a:t>
+              <a:t>écart entre les deux solveurs d'optimisation</a:t>
             </a:r>
             <a:endParaRPr lang="en-US" sz="1050" dirty="0"/>
           </a:p>
@@ -6430,13 +6534,13 @@
             <a:r>
               <a:rPr lang="en-US" sz="1200" b="1" spc="200" kern="0" dirty="0">
                 <a:solidFill>
-                  <a:srgbClr val="2A78D6"/>
-                </a:solidFill>
-                <a:latin typeface="Calibri" pitchFamily="34" charset="0"/>
-                <a:ea typeface="Calibri" pitchFamily="34" charset="-122"/>
-                <a:cs typeface="Calibri" pitchFamily="34" charset="-120"/>
-              </a:rPr>
-              <a:t>LE COPILOTE FINANCIER EN USAGE</a:t>
+                  <a:srgbClr val="EDA100"/>
+                </a:solidFill>
+                <a:latin typeface="Calibri" pitchFamily="34" charset="0"/>
+                <a:ea typeface="Calibri" pitchFamily="34" charset="-122"/>
+                <a:cs typeface="Calibri" pitchFamily="34" charset="-120"/>
+              </a:rPr>
+              <a:t>COPILOTE FINANCIER — AXE TRANSVERSE</a:t>
             </a:r>
             <a:endParaRPr lang="en-US" sz="1200" dirty="0"/>
           </a:p>
@@ -6475,7 +6579,7 @@
                 <a:ea typeface="Cambria" pitchFamily="34" charset="-122"/>
                 <a:cs typeface="Cambria" pitchFamily="34" charset="-120"/>
               </a:rPr>
-              <a:t>La plateforme : cinq pages pour la direction financière</a:t>
+              <a:t>Signaux faibles : texte et réseau de vente</a:t>
             </a:r>
             <a:endParaRPr lang="en-US" sz="2800" dirty="0"/>
           </a:p>
@@ -6489,8 +6593,8 @@
         </p:nvSpPr>
         <p:spPr>
           <a:xfrm>
-            <a:off x="548640" y="1554480"/>
-            <a:ext cx="4160520" cy="4754880"/>
+            <a:off x="548640" y="1600200"/>
+            <a:ext cx="6583680" cy="4663440"/>
           </a:xfrm>
           <a:prstGeom prst="rect">
             <a:avLst/>
@@ -6507,13 +6611,13 @@
                 <a:spcPct val="106000"/>
               </a:lnSpc>
               <a:spcAft>
-                <a:spcPts val="1100"/>
+                <a:spcPts val="1300"/>
               </a:spcAft>
               <a:buSzPct val="100000"/>
               <a:buChar char="•"/>
             </a:pPr>
             <a:r>
-              <a:rPr lang="en-US" sz="1250" dirty="0">
+              <a:rPr lang="en-US" sz="1300" dirty="0">
                 <a:solidFill>
                   <a:srgbClr val="1A1A19"/>
                 </a:solidFill>
@@ -6521,9 +6625,9 @@
                 <a:ea typeface="Calibri" pitchFamily="34" charset="-122"/>
                 <a:cs typeface="Calibri" pitchFamily="34" charset="-120"/>
               </a:rPr>
-              <a:t>Vue d'ensemble : 147 opérations, 421 lots en stock</a:t>
-            </a:r>
-            <a:endParaRPr lang="en-US" sz="1250" dirty="0"/>
+              <a:t>9 688 commentaires libres de vente : moteur de recherche par similarité (TF-IDF + cosinus, corpus de 1 346 documents)</a:t>
+            </a:r>
+            <a:endParaRPr lang="en-US" sz="1300" dirty="0"/>
           </a:p>
           <a:p>
             <a:pPr marL="203200" indent="-203200">
@@ -6531,13 +6635,13 @@
                 <a:spcPct val="106000"/>
               </a:lnSpc>
               <a:spcAft>
-                <a:spcPts val="1100"/>
+                <a:spcPts val="1300"/>
               </a:spcAft>
               <a:buSzPct val="100000"/>
               <a:buChar char="•"/>
             </a:pPr>
             <a:r>
-              <a:rPr lang="en-US" sz="1250" dirty="0">
+              <a:rPr lang="en-US" sz="1300" dirty="0">
                 <a:solidFill>
                   <a:srgbClr val="1A1A19"/>
                 </a:solidFill>
@@ -6545,9 +6649,9 @@
                 <a:ea typeface="Calibri" pitchFamily="34" charset="-122"/>
                 <a:cs typeface="Calibri" pitchFamily="34" charset="-120"/>
               </a:rPr>
-              <a:t>Alertes marge : 10 en alerte sur 68 suffisamment engagées</a:t>
-            </a:r>
-            <a:endParaRPr lang="en-US" sz="1250" dirty="0"/>
+              <a:t>Prédiction du désistement par le texte, fuite contrôlée (314 commentaires écartés) : Naive Bayes F1 = 0,343, préféré à une régression logistique quasi muette</a:t>
+            </a:r>
+            <a:endParaRPr lang="en-US" sz="1300" dirty="0"/>
           </a:p>
           <a:p>
             <a:pPr marL="203200" indent="-203200">
@@ -6555,13 +6659,13 @@
                 <a:spcPct val="106000"/>
               </a:lnSpc>
               <a:spcAft>
-                <a:spcPts val="1100"/>
+                <a:spcPts val="1300"/>
               </a:spcAft>
               <a:buSzPct val="100000"/>
               <a:buChar char="•"/>
             </a:pPr>
             <a:r>
-              <a:rPr lang="en-US" sz="1250" dirty="0">
+              <a:rPr lang="en-US" sz="1300" dirty="0">
                 <a:solidFill>
                   <a:srgbClr val="1A1A19"/>
                 </a:solidFill>
@@ -6569,9 +6673,9 @@
                 <a:ea typeface="Calibri" pitchFamily="34" charset="-122"/>
                 <a:cs typeface="Calibri" pitchFamily="34" charset="-120"/>
               </a:rPr>
-              <a:t>Rythme de vente : simulateur de taux 2026</a:t>
-            </a:r>
-            <a:endParaRPr lang="en-US" sz="1250" dirty="0"/>
+              <a:t>Divergence de Kullback-Leibler (écart entre distributions) : révèle un défaut de saisie sur une agence (90 % de motifs « autres »), pas un profil client</a:t>
+            </a:r>
+            <a:endParaRPr lang="en-US" sz="1300" dirty="0"/>
           </a:p>
           <a:p>
             <a:pPr marL="203200" indent="-203200">
@@ -6579,13 +6683,13 @@
                 <a:spcPct val="106000"/>
               </a:lnSpc>
               <a:spcAft>
-                <a:spcPts val="1100"/>
+                <a:spcPts val="1300"/>
               </a:spcAft>
               <a:buSzPct val="100000"/>
               <a:buChar char="•"/>
             </a:pPr>
             <a:r>
-              <a:rPr lang="en-US" sz="1250" dirty="0">
+              <a:rPr lang="en-US" sz="1300" dirty="0">
                 <a:solidFill>
                   <a:srgbClr val="1A1A19"/>
                 </a:solidFill>
@@ -6593,33 +6697,9 @@
                 <a:ea typeface="Calibri" pitchFamily="34" charset="-122"/>
                 <a:cs typeface="Calibri" pitchFamily="34" charset="-120"/>
               </a:rPr>
-              <a:t>Pilotage des prix : lots hors marché + grille ajustée</a:t>
-            </a:r>
-            <a:endParaRPr lang="en-US" sz="1250" dirty="0"/>
-          </a:p>
-          <a:p>
-            <a:pPr marL="203200" indent="-203200">
-              <a:lnSpc>
-                <a:spcPct val="106000"/>
-              </a:lnSpc>
-              <a:spcAft>
-                <a:spcPts val="1100"/>
-              </a:spcAft>
-              <a:buSzPct val="100000"/>
-              <a:buChar char="•"/>
-            </a:pPr>
-            <a:r>
-              <a:rPr lang="en-US" sz="1250" dirty="0">
-                <a:solidFill>
-                  <a:srgbClr val="1A1A19"/>
-                </a:solidFill>
-                <a:latin typeface="Calibri" pitchFamily="34" charset="0"/>
-                <a:ea typeface="Calibri" pitchFamily="34" charset="-122"/>
-                <a:cs typeface="Calibri" pitchFamily="34" charset="-120"/>
-              </a:rPr>
-              <a:t>Qualité commerciale : alerte de saisie + recherche de dossiers</a:t>
-            </a:r>
-            <a:endParaRPr lang="en-US" sz="1250" dirty="0"/>
+              <a:t>Réseau biparti vendeurs-opérations (209 vendeurs, 711 arêtes) : deux pivots concentrent 51,6 % des dossiers, désistement très contrasté (9,0 % vs 29,6 %)</a:t>
+            </a:r>
+            <a:endParaRPr lang="en-US" sz="1300" dirty="0"/>
           </a:p>
         </p:txBody>
       </p:sp>
@@ -6631,12 +6711,12 @@
         </p:nvSpPr>
         <p:spPr>
           <a:xfrm>
-            <a:off x="4864608" y="1481328"/>
-            <a:ext cx="3529584" cy="2212848"/>
+            <a:off x="7360920" y="1691640"/>
+            <a:ext cx="4251960" cy="1371600"/>
           </a:xfrm>
           <a:prstGeom prst="roundRect">
             <a:avLst>
-              <a:gd name="adj" fmla="val 2479"/>
+              <a:gd name="adj" fmla="val 5333"/>
             </a:avLst>
           </a:prstGeom>
           <a:solidFill>
@@ -6649,51 +6729,106 @@
             <a:prstDash val="solid"/>
           </a:ln>
           <a:effectLst>
-            <a:outerShdw sx="100000" sy="100000" kx="0" ky="0" algn="bl" rotWithShape="0" blurRad="101600" dist="25400" dir="5400000">
+            <a:outerShdw sx="100000" sy="100000" kx="0" ky="0" algn="bl" rotWithShape="0" blurRad="76200" dist="25400" dir="5400000">
               <a:srgbClr val="1A1A19">
-                <a:alpha val="15000"/>
+                <a:alpha val="12000"/>
               </a:srgbClr>
             </a:outerShdw>
           </a:effectLst>
         </p:spPr>
       </p:sp>
-      <p:pic>
-        <p:nvPicPr>
-          <p:cNvPr id="6" name="Image 0" descr="/tmp/claude-0/-home-user-MemoireM2S2/bac073a6-7c4e-552a-9627-815aeb6fe82a/scratchpad/figs/p31-000.png">    </p:cNvPr>
-          <p:cNvPicPr>
-            <a:picLocks noChangeAspect="1"/>
-          </p:cNvPicPr>
-          <p:nvPr/>
-        </p:nvPicPr>
-        <p:blipFill>
-          <a:blip r:embed="rId1"/>
-          <a:srcRect l="0" r="0" t="0" b="0"/>
-          <a:stretch/>
-        </p:blipFill>
-        <p:spPr>
-          <a:xfrm>
-            <a:off x="4937760" y="1554480"/>
-            <a:ext cx="3383280" cy="2066544"/>
-          </a:xfrm>
-          <a:prstGeom prst="rect">
-            <a:avLst/>
-          </a:prstGeom>
-        </p:spPr>
-      </p:pic>
-      <p:sp>
-        <p:nvSpPr>
-          <p:cNvPr id="7" name="Shape 4"/>
-          <p:cNvSpPr/>
-          <p:nvPr/>
-        </p:nvSpPr>
-        <p:spPr>
-          <a:xfrm>
-            <a:off x="8476488" y="1481328"/>
-            <a:ext cx="3255264" cy="2414016"/>
+      <p:sp>
+        <p:nvSpPr>
+          <p:cNvPr id="6" name="Text 4"/>
+          <p:cNvSpPr/>
+          <p:nvPr/>
+        </p:nvSpPr>
+        <p:spPr>
+          <a:xfrm>
+            <a:off x="7470648" y="1764792"/>
+            <a:ext cx="4032504" cy="822960"/>
+          </a:xfrm>
+          <a:prstGeom prst="rect">
+            <a:avLst/>
+          </a:prstGeom>
+          <a:noFill/>
+          <a:ln/>
+        </p:spPr>
+        <p:txBody>
+          <a:bodyPr wrap="square" lIns="0" tIns="0" rIns="0" bIns="0" rtlCol="0" anchor="b"/>
+          <a:lstStyle/>
+          <a:p>
+            <a:pPr algn="l" indent="0" marL="0">
+              <a:buNone/>
+            </a:pPr>
+            <a:r>
+              <a:rPr lang="en-US" sz="2800" b="1" dirty="0">
+                <a:solidFill>
+                  <a:srgbClr val="EDA100"/>
+                </a:solidFill>
+                <a:latin typeface="Cambria" pitchFamily="34" charset="0"/>
+                <a:ea typeface="Cambria" pitchFamily="34" charset="-122"/>
+                <a:cs typeface="Cambria" pitchFamily="34" charset="-120"/>
+              </a:rPr>
+              <a:t>F1 = 0,343</a:t>
+            </a:r>
+            <a:endParaRPr lang="en-US" sz="2800" dirty="0"/>
+          </a:p>
+        </p:txBody>
+      </p:sp>
+      <p:sp>
+        <p:nvSpPr>
+          <p:cNvPr id="7" name="Text 5"/>
+          <p:cNvSpPr/>
+          <p:nvPr/>
+        </p:nvSpPr>
+        <p:spPr>
+          <a:xfrm>
+            <a:off x="7470648" y="2624328"/>
+            <a:ext cx="4032504" cy="384048"/>
+          </a:xfrm>
+          <a:prstGeom prst="rect">
+            <a:avLst/>
+          </a:prstGeom>
+          <a:noFill/>
+          <a:ln/>
+        </p:spPr>
+        <p:txBody>
+          <a:bodyPr wrap="square" lIns="0" tIns="0" rIns="0" bIns="0" rtlCol="0" anchor="t"/>
+          <a:lstStyle/>
+          <a:p>
+            <a:pPr algn="l" indent="0" marL="0">
+              <a:buNone/>
+            </a:pPr>
+            <a:r>
+              <a:rPr lang="en-US" sz="1050" dirty="0">
+                <a:solidFill>
+                  <a:srgbClr val="52514E"/>
+                </a:solidFill>
+                <a:latin typeface="Calibri" pitchFamily="34" charset="0"/>
+                <a:ea typeface="Calibri" pitchFamily="34" charset="-122"/>
+                <a:cs typeface="Calibri" pitchFamily="34" charset="-120"/>
+              </a:rPr>
+              <a:t>Naive Bayes, désistement prédit par le texte</a:t>
+            </a:r>
+            <a:endParaRPr lang="en-US" sz="1050" dirty="0"/>
+          </a:p>
+        </p:txBody>
+      </p:sp>
+      <p:sp>
+        <p:nvSpPr>
+          <p:cNvPr id="8" name="Shape 6"/>
+          <p:cNvSpPr/>
+          <p:nvPr/>
+        </p:nvSpPr>
+        <p:spPr>
+          <a:xfrm>
+            <a:off x="7360920" y="3246120"/>
+            <a:ext cx="4251960" cy="1371600"/>
           </a:xfrm>
           <a:prstGeom prst="roundRect">
             <a:avLst>
-              <a:gd name="adj" fmla="val 2273"/>
+              <a:gd name="adj" fmla="val 5333"/>
             </a:avLst>
           </a:prstGeom>
           <a:solidFill>
@@ -6706,63 +6841,79 @@
             <a:prstDash val="solid"/>
           </a:ln>
           <a:effectLst>
-            <a:outerShdw sx="100000" sy="100000" kx="0" ky="0" algn="bl" rotWithShape="0" blurRad="101600" dist="25400" dir="5400000">
+            <a:outerShdw sx="100000" sy="100000" kx="0" ky="0" algn="bl" rotWithShape="0" blurRad="76200" dist="25400" dir="5400000">
               <a:srgbClr val="1A1A19">
-                <a:alpha val="15000"/>
+                <a:alpha val="12000"/>
               </a:srgbClr>
             </a:outerShdw>
           </a:effectLst>
         </p:spPr>
       </p:sp>
-      <p:pic>
-        <p:nvPicPr>
-          <p:cNvPr id="8" name="Image 1" descr="/tmp/claude-0/-home-user-MemoireM2S2/bac073a6-7c4e-552a-9627-815aeb6fe82a/scratchpad/figs/p31-001.png">    </p:cNvPr>
-          <p:cNvPicPr>
-            <a:picLocks noChangeAspect="1"/>
-          </p:cNvPicPr>
-          <p:nvPr/>
-        </p:nvPicPr>
-        <p:blipFill>
-          <a:blip r:embed="rId2"/>
-          <a:srcRect l="0" r="0" t="0" b="0"/>
-          <a:stretch/>
-        </p:blipFill>
-        <p:spPr>
-          <a:xfrm>
-            <a:off x="8549640" y="1554480"/>
-            <a:ext cx="3108960" cy="2267712"/>
-          </a:xfrm>
-          <a:prstGeom prst="rect">
-            <a:avLst/>
-          </a:prstGeom>
-        </p:spPr>
-      </p:pic>
-      <p:sp>
-        <p:nvSpPr>
-          <p:cNvPr id="9" name="Text 5"/>
-          <p:cNvSpPr/>
-          <p:nvPr/>
-        </p:nvSpPr>
-        <p:spPr>
-          <a:xfrm>
-            <a:off x="4937760" y="3703320"/>
-            <a:ext cx="3383280" cy="274320"/>
-          </a:xfrm>
-          <a:prstGeom prst="rect">
-            <a:avLst/>
-          </a:prstGeom>
-          <a:noFill/>
-          <a:ln/>
-        </p:spPr>
-        <p:txBody>
-          <a:bodyPr wrap="square" lIns="0" tIns="0" rIns="0" bIns="0" rtlCol="0" anchor="ctr"/>
-          <a:lstStyle/>
-          <a:p>
-            <a:pPr algn="ctr" indent="0" marL="0">
-              <a:buNone/>
-            </a:pPr>
-            <a:r>
-              <a:rPr lang="en-US" sz="1000" i="1" dirty="0">
+      <p:sp>
+        <p:nvSpPr>
+          <p:cNvPr id="9" name="Text 7"/>
+          <p:cNvSpPr/>
+          <p:nvPr/>
+        </p:nvSpPr>
+        <p:spPr>
+          <a:xfrm>
+            <a:off x="7470648" y="3319272"/>
+            <a:ext cx="4032504" cy="822960"/>
+          </a:xfrm>
+          <a:prstGeom prst="rect">
+            <a:avLst/>
+          </a:prstGeom>
+          <a:noFill/>
+          <a:ln/>
+        </p:spPr>
+        <p:txBody>
+          <a:bodyPr wrap="square" lIns="0" tIns="0" rIns="0" bIns="0" rtlCol="0" anchor="b"/>
+          <a:lstStyle/>
+          <a:p>
+            <a:pPr algn="l" indent="0" marL="0">
+              <a:buNone/>
+            </a:pPr>
+            <a:r>
+              <a:rPr lang="en-US" sz="2800" b="1" dirty="0">
+                <a:solidFill>
+                  <a:srgbClr val="4A3AA7"/>
+                </a:solidFill>
+                <a:latin typeface="Cambria" pitchFamily="34" charset="0"/>
+                <a:ea typeface="Cambria" pitchFamily="34" charset="-122"/>
+                <a:cs typeface="Cambria" pitchFamily="34" charset="-120"/>
+              </a:rPr>
+              <a:t>51,6 %</a:t>
+            </a:r>
+            <a:endParaRPr lang="en-US" sz="2800" dirty="0"/>
+          </a:p>
+        </p:txBody>
+      </p:sp>
+      <p:sp>
+        <p:nvSpPr>
+          <p:cNvPr id="10" name="Text 8"/>
+          <p:cNvSpPr/>
+          <p:nvPr/>
+        </p:nvSpPr>
+        <p:spPr>
+          <a:xfrm>
+            <a:off x="7470648" y="4178808"/>
+            <a:ext cx="4032504" cy="384048"/>
+          </a:xfrm>
+          <a:prstGeom prst="rect">
+            <a:avLst/>
+          </a:prstGeom>
+          <a:noFill/>
+          <a:ln/>
+        </p:spPr>
+        <p:txBody>
+          <a:bodyPr wrap="square" lIns="0" tIns="0" rIns="0" bIns="0" rtlCol="0" anchor="t"/>
+          <a:lstStyle/>
+          <a:p>
+            <a:pPr algn="l" indent="0" marL="0">
+              <a:buNone/>
+            </a:pPr>
+            <a:r>
+              <a:rPr lang="en-US" sz="1050" dirty="0">
                 <a:solidFill>
                   <a:srgbClr val="52514E"/>
                 </a:solidFill>
@@ -6770,120 +6921,127 @@
                 <a:ea typeface="Calibri" pitchFamily="34" charset="-122"/>
                 <a:cs typeface="Calibri" pitchFamily="34" charset="-120"/>
               </a:rPr>
-              <a:t>Vue d'ensemble</a:t>
-            </a:r>
-            <a:endParaRPr lang="en-US" sz="1000" dirty="0"/>
-          </a:p>
-        </p:txBody>
-      </p:sp>
-      <p:sp>
-        <p:nvSpPr>
-          <p:cNvPr id="10" name="Text 6"/>
-          <p:cNvSpPr/>
-          <p:nvPr/>
-        </p:nvSpPr>
-        <p:spPr>
-          <a:xfrm>
-            <a:off x="8549640" y="3931920"/>
-            <a:ext cx="3108960" cy="274320"/>
-          </a:xfrm>
-          <a:prstGeom prst="rect">
-            <a:avLst/>
-          </a:prstGeom>
-          <a:noFill/>
-          <a:ln/>
-        </p:spPr>
-        <p:txBody>
-          <a:bodyPr wrap="square" lIns="0" tIns="0" rIns="0" bIns="0" rtlCol="0" anchor="ctr"/>
-          <a:lstStyle/>
-          <a:p>
-            <a:pPr algn="ctr" indent="0" marL="0">
-              <a:buNone/>
-            </a:pPr>
-            <a:r>
-              <a:rPr lang="en-US" sz="1000" i="1" dirty="0">
-                <a:solidFill>
-                  <a:srgbClr val="52514E"/>
-                </a:solidFill>
-                <a:latin typeface="Calibri" pitchFamily="34" charset="0"/>
-                <a:ea typeface="Calibri" pitchFamily="34" charset="-122"/>
-                <a:cs typeface="Calibri" pitchFamily="34" charset="-120"/>
-              </a:rPr>
-              <a:t>Alertes marge</a:t>
-            </a:r>
-            <a:endParaRPr lang="en-US" sz="1000" dirty="0"/>
-          </a:p>
-        </p:txBody>
-      </p:sp>
-      <p:sp>
-        <p:nvSpPr>
-          <p:cNvPr id="11" name="Shape 7"/>
-          <p:cNvSpPr/>
-          <p:nvPr/>
-        </p:nvSpPr>
-        <p:spPr>
-          <a:xfrm>
-            <a:off x="4937760" y="4160520"/>
-            <a:ext cx="6720840" cy="1508760"/>
+              <a:t>des dossiers concentrés sur 2 vendeurs pivots</a:t>
+            </a:r>
+            <a:endParaRPr lang="en-US" sz="1050" dirty="0"/>
+          </a:p>
+        </p:txBody>
+      </p:sp>
+      <p:sp>
+        <p:nvSpPr>
+          <p:cNvPr id="11" name="Shape 9"/>
+          <p:cNvSpPr/>
+          <p:nvPr/>
+        </p:nvSpPr>
+        <p:spPr>
+          <a:xfrm>
+            <a:off x="7360920" y="4800600"/>
+            <a:ext cx="4251960" cy="1371600"/>
           </a:xfrm>
           <a:prstGeom prst="roundRect">
             <a:avLst>
-              <a:gd name="adj" fmla="val 4848"/>
+              <a:gd name="adj" fmla="val 5333"/>
             </a:avLst>
           </a:prstGeom>
           <a:solidFill>
-            <a:srgbClr val="F6F8FB"/>
+            <a:srgbClr val="FFFFFF"/>
           </a:solidFill>
           <a:ln w="12700">
             <a:solidFill>
-              <a:srgbClr val="EDA100"/>
+              <a:srgbClr val="E3E7EE"/>
             </a:solidFill>
             <a:prstDash val="solid"/>
           </a:ln>
-        </p:spPr>
-      </p:sp>
-      <p:sp>
-        <p:nvSpPr>
-          <p:cNvPr id="12" name="Text 8"/>
-          <p:cNvSpPr/>
-          <p:nvPr/>
-        </p:nvSpPr>
-        <p:spPr>
-          <a:xfrm>
-            <a:off x="5166360" y="4160520"/>
-            <a:ext cx="6309360" cy="1508760"/>
-          </a:xfrm>
-          <a:prstGeom prst="rect">
-            <a:avLst/>
-          </a:prstGeom>
-          <a:noFill/>
-          <a:ln/>
-        </p:spPr>
-        <p:txBody>
-          <a:bodyPr wrap="square" lIns="0" tIns="0" rIns="0" bIns="0" rtlCol="0" anchor="ctr"/>
-          <a:lstStyle/>
-          <a:p>
-            <a:pPr indent="0" marL="0">
-              <a:buNone/>
-            </a:pPr>
-            <a:r>
-              <a:rPr lang="en-US" sz="1300" i="1" dirty="0">
-                <a:solidFill>
-                  <a:srgbClr val="1A1A19"/>
-                </a:solidFill>
-                <a:latin typeface="Calibri" pitchFamily="34" charset="0"/>
-                <a:ea typeface="Calibri" pitchFamily="34" charset="-122"/>
-                <a:cs typeface="Calibri" pitchFamily="34" charset="-120"/>
-              </a:rPr>
-              <a:t>Leçon de conduite de projet : la première version parlait le vocabulaire des statistiques (F1, R²) — trop technique pour ses utilisateurs. Reconstruite en langage métier.</a:t>
-            </a:r>
-            <a:endParaRPr lang="en-US" sz="1300" dirty="0"/>
-          </a:p>
-        </p:txBody>
-      </p:sp>
-      <p:sp>
-        <p:nvSpPr>
-          <p:cNvPr id="13" name="Text 9"/>
+          <a:effectLst>
+            <a:outerShdw sx="100000" sy="100000" kx="0" ky="0" algn="bl" rotWithShape="0" blurRad="76200" dist="25400" dir="5400000">
+              <a:srgbClr val="1A1A19">
+                <a:alpha val="12000"/>
+              </a:srgbClr>
+            </a:outerShdw>
+          </a:effectLst>
+        </p:spPr>
+      </p:sp>
+      <p:sp>
+        <p:nvSpPr>
+          <p:cNvPr id="12" name="Text 10"/>
+          <p:cNvSpPr/>
+          <p:nvPr/>
+        </p:nvSpPr>
+        <p:spPr>
+          <a:xfrm>
+            <a:off x="7470648" y="4873752"/>
+            <a:ext cx="4032504" cy="822960"/>
+          </a:xfrm>
+          <a:prstGeom prst="rect">
+            <a:avLst/>
+          </a:prstGeom>
+          <a:noFill/>
+          <a:ln/>
+        </p:spPr>
+        <p:txBody>
+          <a:bodyPr wrap="square" lIns="0" tIns="0" rIns="0" bIns="0" rtlCol="0" anchor="b"/>
+          <a:lstStyle/>
+          <a:p>
+            <a:pPr algn="l" indent="0" marL="0">
+              <a:buNone/>
+            </a:pPr>
+            <a:r>
+              <a:rPr lang="en-US" sz="2000" b="1" dirty="0">
+                <a:solidFill>
+                  <a:srgbClr val="E34948"/>
+                </a:solidFill>
+                <a:latin typeface="Cambria" pitchFamily="34" charset="0"/>
+                <a:ea typeface="Cambria" pitchFamily="34" charset="-122"/>
+                <a:cs typeface="Cambria" pitchFamily="34" charset="-120"/>
+              </a:rPr>
+              <a:t>9,0 % / 29,6 %</a:t>
+            </a:r>
+            <a:endParaRPr lang="en-US" sz="2000" dirty="0"/>
+          </a:p>
+        </p:txBody>
+      </p:sp>
+      <p:sp>
+        <p:nvSpPr>
+          <p:cNvPr id="13" name="Text 11"/>
+          <p:cNvSpPr/>
+          <p:nvPr/>
+        </p:nvSpPr>
+        <p:spPr>
+          <a:xfrm>
+            <a:off x="7470648" y="5733288"/>
+            <a:ext cx="4032504" cy="384048"/>
+          </a:xfrm>
+          <a:prstGeom prst="rect">
+            <a:avLst/>
+          </a:prstGeom>
+          <a:noFill/>
+          <a:ln/>
+        </p:spPr>
+        <p:txBody>
+          <a:bodyPr wrap="square" lIns="0" tIns="0" rIns="0" bIns="0" rtlCol="0" anchor="t"/>
+          <a:lstStyle/>
+          <a:p>
+            <a:pPr algn="l" indent="0" marL="0">
+              <a:buNone/>
+            </a:pPr>
+            <a:r>
+              <a:rPr lang="en-US" sz="1050" dirty="0">
+                <a:solidFill>
+                  <a:srgbClr val="52514E"/>
+                </a:solidFill>
+                <a:latin typeface="Calibri" pitchFamily="34" charset="0"/>
+                <a:ea typeface="Calibri" pitchFamily="34" charset="-122"/>
+                <a:cs typeface="Calibri" pitchFamily="34" charset="-120"/>
+              </a:rPr>
+              <a:t>désistement : pivot interne vs prescripteur externe</a:t>
+            </a:r>
+            <a:endParaRPr lang="en-US" sz="1050" dirty="0"/>
+          </a:p>
+        </p:txBody>
+      </p:sp>
+      <p:sp>
+        <p:nvSpPr>
+          <p:cNvPr id="14" name="Text 12"/>
           <p:cNvSpPr/>
           <p:nvPr/>
         </p:nvSpPr>
@@ -6922,7 +7080,7 @@
       </p:sp>
       <p:sp>
         <p:nvSpPr>
-          <p:cNvPr id="14" name="Text 10"/>
+          <p:cNvPr id="15" name="Text 13"/>
           <p:cNvSpPr/>
           <p:nvPr/>
         </p:nvSpPr>
@@ -7024,7 +7182,7 @@
                 <a:ea typeface="Calibri" pitchFamily="34" charset="-122"/>
                 <a:cs typeface="Calibri" pitchFamily="34" charset="-120"/>
               </a:rPr>
-              <a:t>RÉFLEXION TRANSVERSALE</a:t>
+              <a:t>LE COPILOTE FINANCIER EN USAGE</a:t>
             </a:r>
             <a:endParaRPr lang="en-US" sz="1200" dirty="0"/>
           </a:p>
@@ -7063,7 +7221,7 @@
                 <a:ea typeface="Cambria" pitchFamily="34" charset="-122"/>
                 <a:cs typeface="Cambria" pitchFamily="34" charset="-120"/>
               </a:rPr>
-              <a:t>Un traducteur avant d'être un modélisateur</a:t>
+              <a:t>La plateforme : cinq pages pour la direction financière</a:t>
             </a:r>
             <a:endParaRPr lang="en-US" sz="2800" dirty="0"/>
           </a:p>
@@ -7077,24 +7235,31 @@
         </p:nvSpPr>
         <p:spPr>
           <a:xfrm>
-            <a:off x="548640" y="1508760"/>
-            <a:ext cx="11064240" cy="640080"/>
-          </a:xfrm>
-          <a:prstGeom prst="rect">
-            <a:avLst/>
-          </a:prstGeom>
-          <a:noFill/>
-          <a:ln/>
-        </p:spPr>
-        <p:txBody>
-          <a:bodyPr wrap="square" lIns="0" tIns="0" rIns="0" bIns="0" rtlCol="0" anchor="ctr"/>
-          <a:lstStyle/>
-          <a:p>
-            <a:pPr indent="0" marL="0">
-              <a:buNone/>
-            </a:pPr>
-            <a:r>
-              <a:rPr lang="en-US" sz="1500" dirty="0">
+            <a:off x="548640" y="1554480"/>
+            <a:ext cx="4160520" cy="4754880"/>
+          </a:xfrm>
+          <a:prstGeom prst="rect">
+            <a:avLst/>
+          </a:prstGeom>
+          <a:noFill/>
+          <a:ln/>
+        </p:spPr>
+        <p:txBody>
+          <a:bodyPr wrap="square" lIns="0" tIns="0" rIns="0" bIns="0" rtlCol="0" anchor="t"/>
+          <a:lstStyle/>
+          <a:p>
+            <a:pPr marL="203200" indent="-203200">
+              <a:lnSpc>
+                <a:spcPct val="106000"/>
+              </a:lnSpc>
+              <a:spcAft>
+                <a:spcPts val="1100"/>
+              </a:spcAft>
+              <a:buSzPct val="100000"/>
+              <a:buChar char="•"/>
+            </a:pPr>
+            <a:r>
+              <a:rPr lang="en-US" sz="1250" dirty="0">
                 <a:solidFill>
                   <a:srgbClr val="1A1A19"/>
                 </a:solidFill>
@@ -7102,9 +7267,105 @@
                 <a:ea typeface="Calibri" pitchFamily="34" charset="-122"/>
                 <a:cs typeface="Calibri" pitchFamily="34" charset="-120"/>
               </a:rPr>
-              <a:t>Traduire une gêne métier en question calculable, puis un résultat statistique en information sur laquelle décider. Le régime de preuve se déduit de la nature du livrable :</a:t>
-            </a:r>
-            <a:endParaRPr lang="en-US" sz="1500" dirty="0"/>
+              <a:t>Vue d'ensemble : 147 opérations, 421 lots en stock</a:t>
+            </a:r>
+            <a:endParaRPr lang="en-US" sz="1250" dirty="0"/>
+          </a:p>
+          <a:p>
+            <a:pPr marL="203200" indent="-203200">
+              <a:lnSpc>
+                <a:spcPct val="106000"/>
+              </a:lnSpc>
+              <a:spcAft>
+                <a:spcPts val="1100"/>
+              </a:spcAft>
+              <a:buSzPct val="100000"/>
+              <a:buChar char="•"/>
+            </a:pPr>
+            <a:r>
+              <a:rPr lang="en-US" sz="1250" dirty="0">
+                <a:solidFill>
+                  <a:srgbClr val="1A1A19"/>
+                </a:solidFill>
+                <a:latin typeface="Calibri" pitchFamily="34" charset="0"/>
+                <a:ea typeface="Calibri" pitchFamily="34" charset="-122"/>
+                <a:cs typeface="Calibri" pitchFamily="34" charset="-120"/>
+              </a:rPr>
+              <a:t>Alertes marge : 10 en alerte sur 68 suffisamment engagées</a:t>
+            </a:r>
+            <a:endParaRPr lang="en-US" sz="1250" dirty="0"/>
+          </a:p>
+          <a:p>
+            <a:pPr marL="203200" indent="-203200">
+              <a:lnSpc>
+                <a:spcPct val="106000"/>
+              </a:lnSpc>
+              <a:spcAft>
+                <a:spcPts val="1100"/>
+              </a:spcAft>
+              <a:buSzPct val="100000"/>
+              <a:buChar char="•"/>
+            </a:pPr>
+            <a:r>
+              <a:rPr lang="en-US" sz="1250" dirty="0">
+                <a:solidFill>
+                  <a:srgbClr val="1A1A19"/>
+                </a:solidFill>
+                <a:latin typeface="Calibri" pitchFamily="34" charset="0"/>
+                <a:ea typeface="Calibri" pitchFamily="34" charset="-122"/>
+                <a:cs typeface="Calibri" pitchFamily="34" charset="-120"/>
+              </a:rPr>
+              <a:t>Rythme de vente : simulateur de taux 2026</a:t>
+            </a:r>
+            <a:endParaRPr lang="en-US" sz="1250" dirty="0"/>
+          </a:p>
+          <a:p>
+            <a:pPr marL="203200" indent="-203200">
+              <a:lnSpc>
+                <a:spcPct val="106000"/>
+              </a:lnSpc>
+              <a:spcAft>
+                <a:spcPts val="1100"/>
+              </a:spcAft>
+              <a:buSzPct val="100000"/>
+              <a:buChar char="•"/>
+            </a:pPr>
+            <a:r>
+              <a:rPr lang="en-US" sz="1250" dirty="0">
+                <a:solidFill>
+                  <a:srgbClr val="1A1A19"/>
+                </a:solidFill>
+                <a:latin typeface="Calibri" pitchFamily="34" charset="0"/>
+                <a:ea typeface="Calibri" pitchFamily="34" charset="-122"/>
+                <a:cs typeface="Calibri" pitchFamily="34" charset="-120"/>
+              </a:rPr>
+              <a:t>Pilotage des prix : lots hors marché + grille ajustée</a:t>
+            </a:r>
+            <a:endParaRPr lang="en-US" sz="1250" dirty="0"/>
+          </a:p>
+          <a:p>
+            <a:pPr marL="203200" indent="-203200">
+              <a:lnSpc>
+                <a:spcPct val="106000"/>
+              </a:lnSpc>
+              <a:spcAft>
+                <a:spcPts val="1100"/>
+              </a:spcAft>
+              <a:buSzPct val="100000"/>
+              <a:buChar char="•"/>
+            </a:pPr>
+            <a:r>
+              <a:rPr lang="en-US" sz="1250" dirty="0">
+                <a:solidFill>
+                  <a:srgbClr val="1A1A19"/>
+                </a:solidFill>
+                <a:latin typeface="Calibri" pitchFamily="34" charset="0"/>
+                <a:ea typeface="Calibri" pitchFamily="34" charset="-122"/>
+                <a:cs typeface="Calibri" pitchFamily="34" charset="-120"/>
+              </a:rPr>
+              <a:t>Qualité commerciale : alerte de saisie + recherche de dossiers</a:t>
+            </a:r>
+            <a:endParaRPr lang="en-US" sz="1250" dirty="0"/>
           </a:p>
         </p:txBody>
       </p:sp>
@@ -7116,12 +7377,12 @@
         </p:nvSpPr>
         <p:spPr>
           <a:xfrm>
-            <a:off x="1207008" y="2258568"/>
-            <a:ext cx="9747504" cy="4059936"/>
+            <a:off x="4864608" y="1481328"/>
+            <a:ext cx="3529584" cy="2212848"/>
           </a:xfrm>
           <a:prstGeom prst="roundRect">
             <a:avLst>
-              <a:gd name="adj" fmla="val 1351"/>
+              <a:gd name="adj" fmla="val 2479"/>
             </a:avLst>
           </a:prstGeom>
           <a:solidFill>
@@ -7144,7 +7405,7 @@
       </p:sp>
       <p:pic>
         <p:nvPicPr>
-          <p:cNvPr id="6" name="Image 0" descr="/tmp/claude-0/-home-user-MemoireM2S2/bac073a6-7c4e-552a-9627-815aeb6fe82a/scratchpad/figs/p35-000.png">    </p:cNvPr>
+          <p:cNvPr id="6" name="Image 0" descr="/tmp/claude-0/-home-user-MemoireM2S2/bac073a6-7c4e-552a-9627-815aeb6fe82a/scratchpad/figs/p31-000.png">    </p:cNvPr>
           <p:cNvPicPr>
             <a:picLocks noChangeAspect="1"/>
           </p:cNvPicPr>
@@ -7157,8 +7418,8 @@
         </p:blipFill>
         <p:spPr>
           <a:xfrm>
-            <a:off x="1280160" y="2331720"/>
-            <a:ext cx="9601200" cy="3913632"/>
+            <a:off x="4937760" y="1554480"/>
+            <a:ext cx="3383280" cy="2066544"/>
           </a:xfrm>
           <a:prstGeom prst="rect">
             <a:avLst/>
@@ -7167,7 +7428,208 @@
       </p:pic>
       <p:sp>
         <p:nvSpPr>
-          <p:cNvPr id="7" name="Text 4"/>
+          <p:cNvPr id="7" name="Shape 4"/>
+          <p:cNvSpPr/>
+          <p:nvPr/>
+        </p:nvSpPr>
+        <p:spPr>
+          <a:xfrm>
+            <a:off x="8476488" y="1481328"/>
+            <a:ext cx="3255264" cy="2414016"/>
+          </a:xfrm>
+          <a:prstGeom prst="roundRect">
+            <a:avLst>
+              <a:gd name="adj" fmla="val 2273"/>
+            </a:avLst>
+          </a:prstGeom>
+          <a:solidFill>
+            <a:srgbClr val="FFFFFF"/>
+          </a:solidFill>
+          <a:ln w="12700">
+            <a:solidFill>
+              <a:srgbClr val="E3E7EE"/>
+            </a:solidFill>
+            <a:prstDash val="solid"/>
+          </a:ln>
+          <a:effectLst>
+            <a:outerShdw sx="100000" sy="100000" kx="0" ky="0" algn="bl" rotWithShape="0" blurRad="101600" dist="25400" dir="5400000">
+              <a:srgbClr val="1A1A19">
+                <a:alpha val="15000"/>
+              </a:srgbClr>
+            </a:outerShdw>
+          </a:effectLst>
+        </p:spPr>
+      </p:sp>
+      <p:pic>
+        <p:nvPicPr>
+          <p:cNvPr id="8" name="Image 1" descr="/tmp/claude-0/-home-user-MemoireM2S2/bac073a6-7c4e-552a-9627-815aeb6fe82a/scratchpad/figs/p31-001.png">    </p:cNvPr>
+          <p:cNvPicPr>
+            <a:picLocks noChangeAspect="1"/>
+          </p:cNvPicPr>
+          <p:nvPr/>
+        </p:nvPicPr>
+        <p:blipFill>
+          <a:blip r:embed="rId2"/>
+          <a:srcRect l="0" r="0" t="0" b="0"/>
+          <a:stretch/>
+        </p:blipFill>
+        <p:spPr>
+          <a:xfrm>
+            <a:off x="8549640" y="1554480"/>
+            <a:ext cx="3108960" cy="2267712"/>
+          </a:xfrm>
+          <a:prstGeom prst="rect">
+            <a:avLst/>
+          </a:prstGeom>
+        </p:spPr>
+      </p:pic>
+      <p:sp>
+        <p:nvSpPr>
+          <p:cNvPr id="9" name="Text 5"/>
+          <p:cNvSpPr/>
+          <p:nvPr/>
+        </p:nvSpPr>
+        <p:spPr>
+          <a:xfrm>
+            <a:off x="4937760" y="3703320"/>
+            <a:ext cx="3383280" cy="274320"/>
+          </a:xfrm>
+          <a:prstGeom prst="rect">
+            <a:avLst/>
+          </a:prstGeom>
+          <a:noFill/>
+          <a:ln/>
+        </p:spPr>
+        <p:txBody>
+          <a:bodyPr wrap="square" lIns="0" tIns="0" rIns="0" bIns="0" rtlCol="0" anchor="ctr"/>
+          <a:lstStyle/>
+          <a:p>
+            <a:pPr algn="ctr" indent="0" marL="0">
+              <a:buNone/>
+            </a:pPr>
+            <a:r>
+              <a:rPr lang="en-US" sz="1000" i="1" dirty="0">
+                <a:solidFill>
+                  <a:srgbClr val="52514E"/>
+                </a:solidFill>
+                <a:latin typeface="Calibri" pitchFamily="34" charset="0"/>
+                <a:ea typeface="Calibri" pitchFamily="34" charset="-122"/>
+                <a:cs typeface="Calibri" pitchFamily="34" charset="-120"/>
+              </a:rPr>
+              <a:t>Vue d'ensemble</a:t>
+            </a:r>
+            <a:endParaRPr lang="en-US" sz="1000" dirty="0"/>
+          </a:p>
+        </p:txBody>
+      </p:sp>
+      <p:sp>
+        <p:nvSpPr>
+          <p:cNvPr id="10" name="Text 6"/>
+          <p:cNvSpPr/>
+          <p:nvPr/>
+        </p:nvSpPr>
+        <p:spPr>
+          <a:xfrm>
+            <a:off x="8549640" y="3931920"/>
+            <a:ext cx="3108960" cy="274320"/>
+          </a:xfrm>
+          <a:prstGeom prst="rect">
+            <a:avLst/>
+          </a:prstGeom>
+          <a:noFill/>
+          <a:ln/>
+        </p:spPr>
+        <p:txBody>
+          <a:bodyPr wrap="square" lIns="0" tIns="0" rIns="0" bIns="0" rtlCol="0" anchor="ctr"/>
+          <a:lstStyle/>
+          <a:p>
+            <a:pPr algn="ctr" indent="0" marL="0">
+              <a:buNone/>
+            </a:pPr>
+            <a:r>
+              <a:rPr lang="en-US" sz="1000" i="1" dirty="0">
+                <a:solidFill>
+                  <a:srgbClr val="52514E"/>
+                </a:solidFill>
+                <a:latin typeface="Calibri" pitchFamily="34" charset="0"/>
+                <a:ea typeface="Calibri" pitchFamily="34" charset="-122"/>
+                <a:cs typeface="Calibri" pitchFamily="34" charset="-120"/>
+              </a:rPr>
+              <a:t>Alertes marge</a:t>
+            </a:r>
+            <a:endParaRPr lang="en-US" sz="1000" dirty="0"/>
+          </a:p>
+        </p:txBody>
+      </p:sp>
+      <p:sp>
+        <p:nvSpPr>
+          <p:cNvPr id="11" name="Shape 7"/>
+          <p:cNvSpPr/>
+          <p:nvPr/>
+        </p:nvSpPr>
+        <p:spPr>
+          <a:xfrm>
+            <a:off x="4937760" y="4160520"/>
+            <a:ext cx="6720840" cy="1508760"/>
+          </a:xfrm>
+          <a:prstGeom prst="roundRect">
+            <a:avLst>
+              <a:gd name="adj" fmla="val 4848"/>
+            </a:avLst>
+          </a:prstGeom>
+          <a:solidFill>
+            <a:srgbClr val="F6F8FB"/>
+          </a:solidFill>
+          <a:ln w="12700">
+            <a:solidFill>
+              <a:srgbClr val="EDA100"/>
+            </a:solidFill>
+            <a:prstDash val="solid"/>
+          </a:ln>
+        </p:spPr>
+      </p:sp>
+      <p:sp>
+        <p:nvSpPr>
+          <p:cNvPr id="12" name="Text 8"/>
+          <p:cNvSpPr/>
+          <p:nvPr/>
+        </p:nvSpPr>
+        <p:spPr>
+          <a:xfrm>
+            <a:off x="5166360" y="4160520"/>
+            <a:ext cx="6309360" cy="1508760"/>
+          </a:xfrm>
+          <a:prstGeom prst="rect">
+            <a:avLst/>
+          </a:prstGeom>
+          <a:noFill/>
+          <a:ln/>
+        </p:spPr>
+        <p:txBody>
+          <a:bodyPr wrap="square" lIns="0" tIns="0" rIns="0" bIns="0" rtlCol="0" anchor="ctr"/>
+          <a:lstStyle/>
+          <a:p>
+            <a:pPr indent="0" marL="0">
+              <a:buNone/>
+            </a:pPr>
+            <a:r>
+              <a:rPr lang="en-US" sz="1300" i="1" dirty="0">
+                <a:solidFill>
+                  <a:srgbClr val="1A1A19"/>
+                </a:solidFill>
+                <a:latin typeface="Calibri" pitchFamily="34" charset="0"/>
+                <a:ea typeface="Calibri" pitchFamily="34" charset="-122"/>
+                <a:cs typeface="Calibri" pitchFamily="34" charset="-120"/>
+              </a:rPr>
+              <a:t>Leçon de conduite de projet : la première version parlait le vocabulaire des statistiques (F1, R²) — trop technique pour ses utilisateurs. Reconstruite en langage métier.</a:t>
+            </a:r>
+            <a:endParaRPr lang="en-US" sz="1300" dirty="0"/>
+          </a:p>
+        </p:txBody>
+      </p:sp>
+      <p:sp>
+        <p:nvSpPr>
+          <p:cNvPr id="13" name="Text 9"/>
           <p:cNvSpPr/>
           <p:nvPr/>
         </p:nvSpPr>
@@ -7206,7 +7668,7 @@
       </p:sp>
       <p:sp>
         <p:nvSpPr>
-          <p:cNvPr id="8" name="Text 5"/>
+          <p:cNvPr id="14" name="Text 10"/>
           <p:cNvSpPr/>
           <p:nvPr/>
         </p:nvSpPr>
@@ -7308,6 +7770,290 @@
                 <a:ea typeface="Calibri" pitchFamily="34" charset="-122"/>
                 <a:cs typeface="Calibri" pitchFamily="34" charset="-120"/>
               </a:rPr>
+              <a:t>RÉFLEXION TRANSVERSALE</a:t>
+            </a:r>
+            <a:endParaRPr lang="en-US" sz="1200" dirty="0"/>
+          </a:p>
+        </p:txBody>
+      </p:sp>
+      <p:sp>
+        <p:nvSpPr>
+          <p:cNvPr id="3" name="Text 1"/>
+          <p:cNvSpPr/>
+          <p:nvPr/>
+        </p:nvSpPr>
+        <p:spPr>
+          <a:xfrm>
+            <a:off x="548640" y="658368"/>
+            <a:ext cx="10515600" cy="822960"/>
+          </a:xfrm>
+          <a:prstGeom prst="rect">
+            <a:avLst/>
+          </a:prstGeom>
+          <a:noFill/>
+          <a:ln/>
+        </p:spPr>
+        <p:txBody>
+          <a:bodyPr wrap="square" lIns="0" tIns="0" rIns="0" bIns="0" rtlCol="0" anchor="ctr"/>
+          <a:lstStyle/>
+          <a:p>
+            <a:pPr indent="0" marL="0">
+              <a:buNone/>
+            </a:pPr>
+            <a:r>
+              <a:rPr lang="en-US" sz="2800" b="1" dirty="0">
+                <a:solidFill>
+                  <a:srgbClr val="1A1A19"/>
+                </a:solidFill>
+                <a:latin typeface="Cambria" pitchFamily="34" charset="0"/>
+                <a:ea typeface="Cambria" pitchFamily="34" charset="-122"/>
+                <a:cs typeface="Cambria" pitchFamily="34" charset="-120"/>
+              </a:rPr>
+              <a:t>Un traducteur avant d'être un modélisateur</a:t>
+            </a:r>
+            <a:endParaRPr lang="en-US" sz="2800" dirty="0"/>
+          </a:p>
+        </p:txBody>
+      </p:sp>
+      <p:sp>
+        <p:nvSpPr>
+          <p:cNvPr id="4" name="Text 2"/>
+          <p:cNvSpPr/>
+          <p:nvPr/>
+        </p:nvSpPr>
+        <p:spPr>
+          <a:xfrm>
+            <a:off x="548640" y="1508760"/>
+            <a:ext cx="11064240" cy="640080"/>
+          </a:xfrm>
+          <a:prstGeom prst="rect">
+            <a:avLst/>
+          </a:prstGeom>
+          <a:noFill/>
+          <a:ln/>
+        </p:spPr>
+        <p:txBody>
+          <a:bodyPr wrap="square" lIns="0" tIns="0" rIns="0" bIns="0" rtlCol="0" anchor="ctr"/>
+          <a:lstStyle/>
+          <a:p>
+            <a:pPr indent="0" marL="0">
+              <a:buNone/>
+            </a:pPr>
+            <a:r>
+              <a:rPr lang="en-US" sz="1500" dirty="0">
+                <a:solidFill>
+                  <a:srgbClr val="1A1A19"/>
+                </a:solidFill>
+                <a:latin typeface="Calibri" pitchFamily="34" charset="0"/>
+                <a:ea typeface="Calibri" pitchFamily="34" charset="-122"/>
+                <a:cs typeface="Calibri" pitchFamily="34" charset="-120"/>
+              </a:rPr>
+              <a:t>Traduire une gêne métier en question calculable, puis un résultat statistique en information sur laquelle décider. Le régime de preuve se déduit de la nature du livrable :</a:t>
+            </a:r>
+            <a:endParaRPr lang="en-US" sz="1500" dirty="0"/>
+          </a:p>
+        </p:txBody>
+      </p:sp>
+      <p:sp>
+        <p:nvSpPr>
+          <p:cNvPr id="5" name="Shape 3"/>
+          <p:cNvSpPr/>
+          <p:nvPr/>
+        </p:nvSpPr>
+        <p:spPr>
+          <a:xfrm>
+            <a:off x="1207008" y="2258568"/>
+            <a:ext cx="9747504" cy="4059936"/>
+          </a:xfrm>
+          <a:prstGeom prst="roundRect">
+            <a:avLst>
+              <a:gd name="adj" fmla="val 1351"/>
+            </a:avLst>
+          </a:prstGeom>
+          <a:solidFill>
+            <a:srgbClr val="FFFFFF"/>
+          </a:solidFill>
+          <a:ln w="12700">
+            <a:solidFill>
+              <a:srgbClr val="E3E7EE"/>
+            </a:solidFill>
+            <a:prstDash val="solid"/>
+          </a:ln>
+          <a:effectLst>
+            <a:outerShdw sx="100000" sy="100000" kx="0" ky="0" algn="bl" rotWithShape="0" blurRad="101600" dist="25400" dir="5400000">
+              <a:srgbClr val="1A1A19">
+                <a:alpha val="15000"/>
+              </a:srgbClr>
+            </a:outerShdw>
+          </a:effectLst>
+        </p:spPr>
+      </p:sp>
+      <p:pic>
+        <p:nvPicPr>
+          <p:cNvPr id="6" name="Image 0" descr="/tmp/claude-0/-home-user-MemoireM2S2/bac073a6-7c4e-552a-9627-815aeb6fe82a/scratchpad/figs/p35-000.png">    </p:cNvPr>
+          <p:cNvPicPr>
+            <a:picLocks noChangeAspect="1"/>
+          </p:cNvPicPr>
+          <p:nvPr/>
+        </p:nvPicPr>
+        <p:blipFill>
+          <a:blip r:embed="rId1"/>
+          <a:srcRect l="0" r="0" t="0" b="0"/>
+          <a:stretch/>
+        </p:blipFill>
+        <p:spPr>
+          <a:xfrm>
+            <a:off x="1280160" y="2331720"/>
+            <a:ext cx="9601200" cy="3913632"/>
+          </a:xfrm>
+          <a:prstGeom prst="rect">
+            <a:avLst/>
+          </a:prstGeom>
+        </p:spPr>
+      </p:pic>
+      <p:sp>
+        <p:nvSpPr>
+          <p:cNvPr id="7" name="Text 4"/>
+          <p:cNvSpPr/>
+          <p:nvPr/>
+        </p:nvSpPr>
+        <p:spPr>
+          <a:xfrm>
+            <a:off x="548640" y="6510528"/>
+            <a:ext cx="5486400" cy="274320"/>
+          </a:xfrm>
+          <a:prstGeom prst="rect">
+            <a:avLst/>
+          </a:prstGeom>
+          <a:noFill/>
+          <a:ln/>
+        </p:spPr>
+        <p:txBody>
+          <a:bodyPr wrap="square" lIns="0" tIns="0" rIns="0" bIns="0" rtlCol="0" anchor="ctr"/>
+          <a:lstStyle/>
+          <a:p>
+            <a:pPr indent="0" marL="0">
+              <a:buNone/>
+            </a:pPr>
+            <a:r>
+              <a:rPr lang="en-US" sz="900" dirty="0">
+                <a:solidFill>
+                  <a:srgbClr val="9A9A95"/>
+                </a:solidFill>
+                <a:latin typeface="Calibri" pitchFamily="34" charset="0"/>
+                <a:ea typeface="Calibri" pitchFamily="34" charset="-122"/>
+                <a:cs typeface="Calibri" pitchFamily="34" charset="-120"/>
+              </a:rPr>
+              <a:t>Copilote Financier — Groupe Angelotti</a:t>
+            </a:r>
+            <a:endParaRPr lang="en-US" sz="900" dirty="0"/>
+          </a:p>
+        </p:txBody>
+      </p:sp>
+      <p:sp>
+        <p:nvSpPr>
+          <p:cNvPr id="8" name="Text 5"/>
+          <p:cNvSpPr/>
+          <p:nvPr/>
+        </p:nvSpPr>
+        <p:spPr>
+          <a:xfrm>
+            <a:off x="11430000" y="6510528"/>
+            <a:ext cx="365760" cy="274320"/>
+          </a:xfrm>
+          <a:prstGeom prst="rect">
+            <a:avLst/>
+          </a:prstGeom>
+          <a:noFill/>
+          <a:ln/>
+        </p:spPr>
+        <p:txBody>
+          <a:bodyPr wrap="square" lIns="0" tIns="0" rIns="0" bIns="0" rtlCol="0" anchor="ctr"/>
+          <a:lstStyle/>
+          <a:p>
+            <a:pPr algn="r" indent="0" marL="0">
+              <a:buNone/>
+            </a:pPr>
+            <a:r>
+              <a:rPr lang="en-US" sz="900" dirty="0">
+                <a:solidFill>
+                  <a:srgbClr val="9A9A95"/>
+                </a:solidFill>
+                <a:latin typeface="Calibri" pitchFamily="34" charset="0"/>
+                <a:ea typeface="Calibri" pitchFamily="34" charset="-122"/>
+                <a:cs typeface="Calibri" pitchFamily="34" charset="-120"/>
+              </a:rPr>
+              <a:t>17</a:t>
+            </a:r>
+            <a:endParaRPr lang="en-US" sz="900" dirty="0"/>
+          </a:p>
+        </p:txBody>
+      </p:sp>
+    </p:spTree>
+  </p:cSld>
+  <p:clrMapOvr>
+    <a:masterClrMapping/>
+  </p:clrMapOvr>
+</p:sld>
+</file>
+
+<file path=ppt/slides/slide18.xml><?xml version="1.0" encoding="utf-8"?>
+<p:sld xmlns:a="http://schemas.openxmlformats.org/drawingml/2006/main" xmlns:r="http://schemas.openxmlformats.org/officeDocument/2006/relationships" xmlns:p="http://schemas.openxmlformats.org/presentationml/2006/main">
+  <p:cSld name="Slide 18">
+    <p:bg>
+      <p:bgPr>
+        <a:solidFill>
+          <a:srgbClr val="FFFFFF"/>
+        </a:solidFill>
+      </p:bgPr>
+    </p:bg>
+    <p:spTree>
+      <p:nvGrpSpPr>
+        <p:cNvPr id="1" name=""/>
+        <p:cNvGrpSpPr/>
+        <p:nvPr/>
+      </p:nvGrpSpPr>
+      <p:grpSpPr>
+        <a:xfrm>
+          <a:off x="0" y="0"/>
+          <a:ext cx="0" cy="0"/>
+          <a:chOff x="0" y="0"/>
+          <a:chExt cx="0" cy="0"/>
+        </a:xfrm>
+      </p:grpSpPr>
+      <p:sp>
+        <p:nvSpPr>
+          <p:cNvPr id="2" name="Text 0"/>
+          <p:cNvSpPr/>
+          <p:nvPr/>
+        </p:nvSpPr>
+        <p:spPr>
+          <a:xfrm>
+            <a:off x="548640" y="384048"/>
+            <a:ext cx="8229600" cy="320040"/>
+          </a:xfrm>
+          <a:prstGeom prst="rect">
+            <a:avLst/>
+          </a:prstGeom>
+          <a:noFill/>
+          <a:ln/>
+        </p:spPr>
+        <p:txBody>
+          <a:bodyPr wrap="square" lIns="0" tIns="0" rIns="0" bIns="0" rtlCol="0" anchor="ctr"/>
+          <a:lstStyle/>
+          <a:p>
+            <a:pPr indent="0" marL="0">
+              <a:buNone/>
+            </a:pPr>
+            <a:r>
+              <a:rPr lang="en-US" sz="1200" b="1" spc="200" kern="0" dirty="0">
+                <a:solidFill>
+                  <a:srgbClr val="2A78D6"/>
+                </a:solidFill>
+                <a:latin typeface="Calibri" pitchFamily="34" charset="0"/>
+                <a:ea typeface="Calibri" pitchFamily="34" charset="-122"/>
+                <a:cs typeface="Calibri" pitchFamily="34" charset="-120"/>
+              </a:rPr>
               <a:t>PERSPECTIVES</a:t>
             </a:r>
             <a:endParaRPr lang="en-US" sz="1200" dirty="0"/>
@@ -7986,7 +8732,7 @@
                 <a:ea typeface="Calibri" pitchFamily="34" charset="-122"/>
                 <a:cs typeface="Calibri" pitchFamily="34" charset="-120"/>
               </a:rPr>
-              <a:t>17</a:t>
+              <a:t>18</a:t>
             </a:r>
             <a:endParaRPr lang="en-US" sz="900" dirty="0"/>
           </a:p>
@@ -8000,9 +8746,9 @@
 </p:sld>
 </file>
 
-<file path=ppt/slides/slide18.xml><?xml version="1.0" encoding="utf-8"?>
+<file path=ppt/slides/slide19.xml><?xml version="1.0" encoding="utf-8"?>
 <p:sld xmlns:a="http://schemas.openxmlformats.org/drawingml/2006/main" xmlns:r="http://schemas.openxmlformats.org/officeDocument/2006/relationships" xmlns:p="http://schemas.openxmlformats.org/presentationml/2006/main">
-  <p:cSld name="Slide 18">
+  <p:cSld name="Slide 19">
     <p:bg>
       <p:bgPr>
         <a:solidFill>

</xml_diff>